<commit_message>
Add Team Oscar credit, Agenda cleanup, and dashboard screenshots to deck
- Add "Team Oscar" next to presenter names on the title and closing
  slides
- Remove the Capgemini/Snowflake logos and the stale "Business Value &
  Judging Criteria" bullet from the Agenda slide
- Add real Portfolio & Risk, Trend Analysis, Usage, and Accuracy
  dashboard screenshots to the Dashboards & MCP Integration slide as a
  2x2 grid, replacing the outdated pre-rename screenshot

Co-Authored-By: Claude Sonnet 5 <noreply@anthropic.com>
Claude-Session: https://claude.ai/code/session_014tgQKVUCCAHyjbKEg7CGuq
</commit_message>
<xml_diff>
--- a/docs/Unified_Enterprise_AI_Agents_Platform.pptx
+++ b/docs/Unified_Enterprise_AI_Agents_Platform.pptx
@@ -3511,7 +3511,7 @@
         <p:spPr>
           <a:xfrm>
             <a:off x="914400" y="5257800"/>
-            <a:ext cx="10332720" cy="457200"/>
+            <a:ext cx="10332720" cy="850000"/>
           </a:xfrm>
           <a:prstGeom prst="rect">
             <a:avLst/>
@@ -3523,6 +3523,22 @@
             <a:spAutoFit/>
           </a:bodyPr>
           <a:lstStyle/>
+          <a:p>
+            <a:pPr algn="ctr">
+              <a:lnSpc>
+                <a:spcPct val="100000"/>
+              </a:lnSpc>
+            </a:pPr>
+            <a:r>
+              <a:rPr sz="1800" b="1" i="0">
+                <a:solidFill>
+                  <a:srgbClr val="E8A82A"/>
+                </a:solidFill>
+                <a:latin typeface="Calibri"/>
+              </a:rPr>
+              <a:t>Team Oscar</a:t>
+            </a:r>
+          </a:p>
           <a:p>
             <a:pPr algn="ctr">
               <a:lnSpc>
@@ -4600,26 +4616,118 @@
       </p:sp>
       <p:pic>
         <p:nvPicPr>
-          <p:cNvPr id="7" name="Picture 6" descr="streamlite15.png"/>
+          <p:cNvPr id="7" name="Dashboard Portfolio Risk Screenshot" descr="Portfolio and Risk dashboard"/>
           <p:cNvPicPr>
             <a:picLocks noChangeAspect="1"/>
           </p:cNvPicPr>
           <p:nvPr/>
         </p:nvPicPr>
         <p:blipFill>
-          <a:blip r:embed="rId2"/>
+          <a:blip r:embed="rId5"/>
           <a:stretch>
             <a:fillRect/>
           </a:stretch>
         </p:blipFill>
         <p:spPr>
           <a:xfrm>
-            <a:off x="6309360" y="1780697"/>
-            <a:ext cx="5303520" cy="2473646"/>
-          </a:xfrm>
-          <a:prstGeom prst="rect">
-            <a:avLst/>
-          </a:prstGeom>
+            <a:off x="6309360" y="1869359"/>
+            <a:ext cx="2621280" cy="1297867"/>
+          </a:xfrm>
+          <a:prstGeom prst="rect">
+            <a:avLst/>
+          </a:prstGeom>
+          <a:ln w="9525">
+            <a:solidFill>
+              <a:srgbClr val="E2E5EA"/>
+            </a:solidFill>
+          </a:ln>
+        </p:spPr>
+      </p:pic>
+      <p:pic>
+        <p:nvPicPr>
+          <p:cNvPr id="13" name="Dashboard Trend Analysis Screenshot" descr="Trend Analysis dashboard"/>
+          <p:cNvPicPr>
+            <a:picLocks noChangeAspect="1"/>
+          </p:cNvPicPr>
+          <p:nvPr/>
+        </p:nvPicPr>
+        <p:blipFill>
+          <a:blip r:embed="rId6"/>
+          <a:stretch>
+            <a:fillRect/>
+          </a:stretch>
+        </p:blipFill>
+        <p:spPr>
+          <a:xfrm>
+            <a:off x="8991600" y="1929627"/>
+            <a:ext cx="2621280" cy="1177332"/>
+          </a:xfrm>
+          <a:prstGeom prst="rect">
+            <a:avLst/>
+          </a:prstGeom>
+          <a:ln w="9525">
+            <a:solidFill>
+              <a:srgbClr val="E2E5EA"/>
+            </a:solidFill>
+          </a:ln>
+        </p:spPr>
+      </p:pic>
+      <p:pic>
+        <p:nvPicPr>
+          <p:cNvPr id="14" name="Dashboard Usage Screenshot" descr="Agent usage across all channels"/>
+          <p:cNvPicPr>
+            <a:picLocks noChangeAspect="1"/>
+          </p:cNvPicPr>
+          <p:nvPr/>
+        </p:nvPicPr>
+        <p:blipFill>
+          <a:blip r:embed="rId3"/>
+          <a:stretch>
+            <a:fillRect/>
+          </a:stretch>
+        </p:blipFill>
+        <p:spPr>
+          <a:xfrm>
+            <a:off x="6309360" y="3512857"/>
+            <a:ext cx="2621280" cy="1083174"/>
+          </a:xfrm>
+          <a:prstGeom prst="rect">
+            <a:avLst/>
+          </a:prstGeom>
+          <a:ln w="9525">
+            <a:solidFill>
+              <a:srgbClr val="E2E5EA"/>
+            </a:solidFill>
+          </a:ln>
+        </p:spPr>
+      </p:pic>
+      <p:pic>
+        <p:nvPicPr>
+          <p:cNvPr id="15" name="Dashboard Accuracy Screenshot" descr="Agent accuracy, Streamlit only"/>
+          <p:cNvPicPr>
+            <a:picLocks noChangeAspect="1"/>
+          </p:cNvPicPr>
+          <p:nvPr/>
+        </p:nvPicPr>
+        <p:blipFill>
+          <a:blip r:embed="rId4"/>
+          <a:stretch>
+            <a:fillRect/>
+          </a:stretch>
+        </p:blipFill>
+        <p:spPr>
+          <a:xfrm>
+            <a:off x="8991600" y="3497640"/>
+            <a:ext cx="2621280" cy="1113608"/>
+          </a:xfrm>
+          <a:prstGeom prst="rect">
+            <a:avLst/>
+          </a:prstGeom>
+          <a:ln w="9525">
+            <a:solidFill>
+              <a:srgbClr val="E2E5EA"/>
+            </a:solidFill>
+          </a:ln>
         </p:spPr>
       </p:pic>
       <p:sp>
@@ -5142,7 +5250,7 @@
         <p:spPr>
           <a:xfrm>
             <a:off x="914400" y="4846320"/>
-            <a:ext cx="10332720" cy="457200"/>
+            <a:ext cx="10332720" cy="877200"/>
           </a:xfrm>
           <a:prstGeom prst="rect">
             <a:avLst/>
@@ -5161,6 +5269,22 @@
               </a:lnSpc>
             </a:pPr>
             <a:r>
+              <a:rPr sz="1800" b="1" i="0">
+                <a:solidFill>
+                  <a:srgbClr val="E8A82A"/>
+                </a:solidFill>
+                <a:latin typeface="Calibri"/>
+              </a:rPr>
+              <a:t>Team Oscar</a:t>
+            </a:r>
+          </a:p>
+          <a:p>
+            <a:pPr algn="ctr">
+              <a:lnSpc>
+                <a:spcPct val="100000"/>
+              </a:lnSpc>
+            </a:pPr>
+            <a:r>
               <a:rPr sz="1700" b="1" i="0">
                 <a:solidFill>
                   <a:srgbClr val="FFFFFF"/>
@@ -5180,7 +5304,7 @@
         </p:nvSpPr>
         <p:spPr>
           <a:xfrm>
-            <a:off x="914400" y="5349240"/>
+            <a:off x="914400" y="5769240"/>
             <a:ext cx="10332720" cy="365760"/>
           </a:xfrm>
           <a:prstGeom prst="rect">
@@ -5358,128 +5482,6 @@
       </p:sp>
       <p:sp>
         <p:nvSpPr>
-          <p:cNvPr id="5" name="TextBox 4"/>
-          <p:cNvSpPr txBox="1"/>
-          <p:nvPr/>
-        </p:nvSpPr>
-        <p:spPr>
-          <a:xfrm>
-            <a:off x="8595360" y="292608"/>
-            <a:ext cx="1316736" cy="301752"/>
-          </a:xfrm>
-          <a:prstGeom prst="rect">
-            <a:avLst/>
-          </a:prstGeom>
-          <a:noFill/>
-        </p:spPr>
-        <p:txBody>
-          <a:bodyPr wrap="none">
-            <a:spAutoFit/>
-          </a:bodyPr>
-          <a:lstStyle/>
-          <a:p>
-            <a:pPr algn="l"/>
-            <a:r>
-              <a:rPr sz="1439" b="1">
-                <a:solidFill>
-                  <a:srgbClr val="FFFFFF"/>
-                </a:solidFill>
-                <a:latin typeface="Georgia"/>
-              </a:rPr>
-              <a:t>Capgemini</a:t>
-            </a:r>
-          </a:p>
-        </p:txBody>
-      </p:sp>
-      <p:sp>
-        <p:nvSpPr>
-          <p:cNvPr id="6" name="Rectangle 5"/>
-          <p:cNvSpPr/>
-          <p:nvPr/>
-        </p:nvSpPr>
-        <p:spPr>
-          <a:xfrm>
-            <a:off x="8595360" y="566928"/>
-            <a:ext cx="630936" cy="40640"/>
-          </a:xfrm>
-          <a:prstGeom prst="rect">
-            <a:avLst/>
-          </a:prstGeom>
-          <a:solidFill>
-            <a:srgbClr val="0070AD"/>
-          </a:solidFill>
-          <a:ln>
-            <a:noFill/>
-          </a:ln>
-          <a:effectLst/>
-        </p:spPr>
-        <p:style>
-          <a:lnRef idx="1">
-            <a:schemeClr val="accent1"/>
-          </a:lnRef>
-          <a:fillRef idx="3">
-            <a:schemeClr val="accent1"/>
-          </a:fillRef>
-          <a:effectRef idx="2">
-            <a:schemeClr val="accent1"/>
-          </a:effectRef>
-          <a:fontRef idx="minor">
-            <a:schemeClr val="lt1"/>
-          </a:fontRef>
-        </p:style>
-        <p:txBody>
-          <a:bodyPr rtlCol="0" anchor="ctr"/>
-          <a:lstStyle/>
-          <a:p>
-            <a:pPr algn="ctr"/>
-          </a:p>
-        </p:txBody>
-      </p:sp>
-      <p:sp>
-        <p:nvSpPr>
-          <p:cNvPr id="7" name="TextBox 6"/>
-          <p:cNvSpPr txBox="1"/>
-          <p:nvPr/>
-        </p:nvSpPr>
-        <p:spPr>
-          <a:xfrm>
-            <a:off x="10241280" y="292608"/>
-            <a:ext cx="1426464" cy="301752"/>
-          </a:xfrm>
-          <a:prstGeom prst="rect">
-            <a:avLst/>
-          </a:prstGeom>
-          <a:noFill/>
-        </p:spPr>
-        <p:txBody>
-          <a:bodyPr wrap="none">
-            <a:spAutoFit/>
-          </a:bodyPr>
-          <a:lstStyle/>
-          <a:p>
-            <a:pPr algn="l"/>
-            <a:r>
-              <a:rPr sz="1439" b="1">
-                <a:solidFill>
-                  <a:srgbClr val="29B5E8"/>
-                </a:solidFill>
-              </a:rPr>
-              <a:t>❄ </a:t>
-            </a:r>
-            <a:r>
-              <a:rPr sz="1439" b="1">
-                <a:solidFill>
-                  <a:srgbClr val="FFFFFF"/>
-                </a:solidFill>
-                <a:latin typeface="Calibri"/>
-              </a:rPr>
-              <a:t>Snowflake</a:t>
-            </a:r>
-          </a:p>
-        </p:txBody>
-      </p:sp>
-      <p:sp>
-        <p:nvSpPr>
           <p:cNvPr id="8" name="TextBox 7"/>
           <p:cNvSpPr txBox="1"/>
           <p:nvPr/>
@@ -5593,22 +5595,6 @@
                 <a:latin typeface="Calibri"/>
               </a:rPr>
               <a:t>▸  Dashboards &amp; MCP Integration — usage, trust, and extensibility</a:t>
-            </a:r>
-          </a:p>
-          <a:p>
-            <a:pPr>
-              <a:spcAft>
-                <a:spcPts val="1800"/>
-              </a:spcAft>
-            </a:pPr>
-            <a:r>
-              <a:rPr sz="2000">
-                <a:solidFill>
-                  <a:srgbClr val="1A1A1A"/>
-                </a:solidFill>
-                <a:latin typeface="Calibri"/>
-              </a:rPr>
-              <a:t>▸  Business Value &amp; Judging Criteria</a:t>
             </a:r>
           </a:p>
         </p:txBody>

</xml_diff>

<commit_message>
Add problem statement, benefits, and judging criteria content
- ARCHITECTURE.md: add an explicit "Problem statement" line and a new
  "Benefits" section covering user-facing outcomes
- Deck: add a bolded problem strapline to "The Problem" slide, plus new
  "Benefits" and "Judging Criteria" slides before the closing slide

Co-Authored-By: Claude Sonnet 5 <noreply@anthropic.com>
Claude-Session: https://claude.ai/code/session_014tgQKVUCCAHyjbKEg7CGuq
</commit_message>
<xml_diff>
--- a/docs/Unified_Enterprise_AI_Agents_Platform.pptx
+++ b/docs/Unified_Enterprise_AI_Agents_Platform.pptx
@@ -87,6 +87,8 @@
     <p:sldId id="264" r:id="rId15"/>
     <p:sldId id="265" r:id="rId16"/>
     <p:sldId id="266" r:id="rId17"/>
+    <p:sldId id="270" r:id="rId20"/>
+    <p:sldId id="271" r:id="rId21"/>
     <p:sldId id="268" r:id="rId19"/>
   </p:sldIdLst>
   <p:sldSz cx="12191695" cy="6858000" type="screen4x3"/>
@@ -5343,6 +5345,1159 @@
 </p:sld>
 </file>
 
+<file path=ppt\slides\slide15.xml><?xml version="1.0" encoding="utf-8"?>
+<p:sld xmlns:a="http://schemas.openxmlformats.org/drawingml/2006/main" xmlns:p="http://schemas.openxmlformats.org/presentationml/2006/main" xmlns:r="http://schemas.openxmlformats.org/officeDocument/2006/relationships">
+  <p:cSld>
+    <p:spTree>
+      <p:nvGrpSpPr>
+        <p:cNvPr id="1" name=""/>
+        <p:cNvGrpSpPr/>
+        <p:nvPr/>
+      </p:nvGrpSpPr>
+      <p:grpSpPr/>
+      <p:sp>
+        <p:nvSpPr>
+          <p:cNvPr id="2" name="Rectangle 1"/>
+          <p:cNvSpPr/>
+          <p:nvPr/>
+        </p:nvSpPr>
+        <p:spPr>
+          <a:xfrm>
+            <a:off x="0" y="0"/>
+            <a:ext cx="12191695" cy="6858000"/>
+          </a:xfrm>
+          <a:prstGeom prst="rect">
+            <a:avLst/>
+          </a:prstGeom>
+          <a:solidFill>
+            <a:srgbClr val="FFFFFF"/>
+          </a:solidFill>
+          <a:ln>
+            <a:noFill/>
+          </a:ln>
+          <a:effectLst/>
+        </p:spPr>
+        <p:style>
+          <a:lnRef idx="1">
+            <a:schemeClr val="accent1"/>
+          </a:lnRef>
+          <a:fillRef idx="3">
+            <a:schemeClr val="accent1"/>
+          </a:fillRef>
+          <a:effectRef idx="2">
+            <a:schemeClr val="accent1"/>
+          </a:effectRef>
+          <a:fontRef idx="minor">
+            <a:schemeClr val="lt1"/>
+          </a:fontRef>
+        </p:style>
+        <p:txBody>
+          <a:bodyPr rtlCol="0" anchor="ctr"/>
+          <a:lstStyle/>
+          <a:p>
+            <a:pPr algn="ctr"/>
+          </a:p>
+        </p:txBody>
+      </p:sp>
+      <p:sp>
+        <p:nvSpPr>
+          <p:cNvPr id="3" name="Rectangle 2"/>
+          <p:cNvSpPr/>
+          <p:nvPr/>
+        </p:nvSpPr>
+        <p:spPr>
+          <a:xfrm>
+            <a:off x="0" y="0"/>
+            <a:ext cx="12191695" cy="1051560"/>
+          </a:xfrm>
+          <a:prstGeom prst="rect">
+            <a:avLst/>
+          </a:prstGeom>
+          <a:solidFill>
+            <a:srgbClr val="0B1F3A"/>
+          </a:solidFill>
+          <a:ln>
+            <a:noFill/>
+          </a:ln>
+          <a:effectLst/>
+        </p:spPr>
+        <p:style>
+          <a:lnRef idx="1">
+            <a:schemeClr val="accent1"/>
+          </a:lnRef>
+          <a:fillRef idx="3">
+            <a:schemeClr val="accent1"/>
+          </a:fillRef>
+          <a:effectRef idx="2">
+            <a:schemeClr val="accent1"/>
+          </a:effectRef>
+          <a:fontRef idx="minor">
+            <a:schemeClr val="lt1"/>
+          </a:fontRef>
+        </p:style>
+        <p:txBody>
+          <a:bodyPr rtlCol="0" anchor="ctr"/>
+          <a:lstStyle/>
+          <a:p>
+            <a:pPr algn="ctr"/>
+          </a:p>
+        </p:txBody>
+      </p:sp>
+      <p:sp>
+        <p:nvSpPr>
+          <p:cNvPr id="4" name="TextBox 3"/>
+          <p:cNvSpPr txBox="1"/>
+          <p:nvPr/>
+        </p:nvSpPr>
+        <p:spPr>
+          <a:xfrm>
+            <a:off x="548640" y="256032"/>
+            <a:ext cx="7315200" cy="548640"/>
+          </a:xfrm>
+          <a:prstGeom prst="rect">
+            <a:avLst/>
+          </a:prstGeom>
+          <a:noFill/>
+        </p:spPr>
+        <p:txBody>
+          <a:bodyPr wrap="square" anchor="t">
+            <a:spAutoFit/>
+          </a:bodyPr>
+          <a:lstStyle/>
+          <a:p>
+            <a:pPr algn="l">
+              <a:lnSpc>
+                <a:spcPct val="100000"/>
+              </a:lnSpc>
+            </a:pPr>
+            <a:r>
+              <a:rPr sz="3000" b="1" i="0">
+                <a:solidFill>
+                  <a:srgbClr val="FFFFFF"/>
+                </a:solidFill>
+                <a:latin typeface="Georgia"/>
+              </a:rPr>
+              <a:t>Benefits</a:t>
+            </a:r>
+          </a:p>
+        </p:txBody>
+      </p:sp>
+      <p:sp>
+        <p:nvSpPr>
+          <p:cNvPr id="8" name="TextBox 7"/>
+          <p:cNvSpPr txBox="1"/>
+          <p:nvPr/>
+        </p:nvSpPr>
+        <p:spPr>
+          <a:xfrm>
+            <a:off x="914400" y="1645920"/>
+            <a:ext cx="10058400" cy="4572000"/>
+          </a:xfrm>
+          <a:prstGeom prst="rect">
+            <a:avLst/>
+          </a:prstGeom>
+          <a:noFill/>
+        </p:spPr>
+        <p:txBody>
+          <a:bodyPr wrap="square">
+            <a:spAutoFit/>
+          </a:bodyPr>
+          <a:lstStyle/>
+          <a:p>
+            <a:pPr>
+              <a:spcAft>
+                <a:spcPts val="2400"/>
+              </a:spcAft>
+            </a:pPr>
+            <a:r>
+              <a:rPr sz="2000">
+                <a:solidFill>
+                  <a:srgbClr val="1A1A1A"/>
+                </a:solidFill>
+                <a:latin typeface="Calibri"/>
+              </a:rPr>
+              <a:t>▸  Faster answers — hours of waiting on a specialist collapse into a single conversation</a:t>
+            </a:r>
+          </a:p>
+          <a:p>
+            <a:pPr>
+              <a:spcAft>
+                <a:spcPts val="2400"/>
+              </a:spcAft>
+            </a:pPr>
+            <a:r>
+              <a:rPr sz="2000">
+                <a:solidFill>
+                  <a:srgbClr val="1A1A1A"/>
+                </a:solidFill>
+                <a:latin typeface="Calibri"/>
+              </a:rPr>
+              <a:t>▸  No new tools to learn — plain English in, no SQL, no BI dashboards, no ticket queue</a:t>
+            </a:r>
+          </a:p>
+          <a:p>
+            <a:pPr>
+              <a:spcAft>
+                <a:spcPts val="2400"/>
+              </a:spcAft>
+            </a:pPr>
+            <a:r>
+              <a:rPr sz="2000">
+                <a:solidFill>
+                  <a:srgbClr val="1A1A1A"/>
+                </a:solidFill>
+                <a:latin typeface="Calibri"/>
+              </a:rPr>
+              <a:t>▸  Trustworthy by design — every answer shows its SQL or source citation, so it can be verified</a:t>
+            </a:r>
+          </a:p>
+          <a:p>
+            <a:pPr>
+              <a:spcAft>
+                <a:spcPts val="2400"/>
+              </a:spcAft>
+            </a:pPr>
+            <a:r>
+              <a:rPr sz="2000">
+                <a:solidFill>
+                  <a:srgbClr val="1A1A1A"/>
+                </a:solidFill>
+                <a:latin typeface="Calibri"/>
+              </a:rPr>
+              <a:t>▸  One integration, many channels — the same agent serves Streamlit today and any MCP client tomorrow</a:t>
+            </a:r>
+          </a:p>
+        </p:txBody>
+      </p:sp>
+      <p:sp>
+        <p:nvSpPr>
+          <p:cNvPr id="9" name="TextBox 8"/>
+          <p:cNvSpPr txBox="1"/>
+          <p:nvPr/>
+        </p:nvSpPr>
+        <p:spPr>
+          <a:xfrm>
+            <a:off x="457200" y="6473952"/>
+            <a:ext cx="5486400" cy="320040"/>
+          </a:xfrm>
+          <a:prstGeom prst="rect">
+            <a:avLst/>
+          </a:prstGeom>
+          <a:noFill/>
+        </p:spPr>
+        <p:txBody>
+          <a:bodyPr wrap="square" anchor="t">
+            <a:spAutoFit/>
+          </a:bodyPr>
+          <a:lstStyle/>
+          <a:p>
+            <a:pPr algn="l">
+              <a:lnSpc>
+                <a:spcPct val="100000"/>
+              </a:lnSpc>
+            </a:pPr>
+            <a:r>
+              <a:rPr sz="900" b="0" i="1">
+                <a:solidFill>
+                  <a:srgbClr val="5A6370"/>
+                </a:solidFill>
+                <a:latin typeface="Calibri"/>
+              </a:rPr>
+              <a:t>Unified Enterprise AI Agents Platform  |  Capgemini x Snowflake Hackathon</a:t>
+            </a:r>
+          </a:p>
+        </p:txBody>
+      </p:sp>
+      <p:sp>
+        <p:nvSpPr>
+          <p:cNvPr id="10" name="TextBox 9"/>
+          <p:cNvSpPr txBox="1"/>
+          <p:nvPr/>
+        </p:nvSpPr>
+        <p:spPr>
+          <a:xfrm>
+            <a:off x="11247120" y="6473952"/>
+            <a:ext cx="731520" cy="320040"/>
+          </a:xfrm>
+          <a:prstGeom prst="rect">
+            <a:avLst/>
+          </a:prstGeom>
+          <a:noFill/>
+        </p:spPr>
+        <p:txBody>
+          <a:bodyPr wrap="square" anchor="t">
+            <a:spAutoFit/>
+          </a:bodyPr>
+          <a:lstStyle/>
+          <a:p>
+            <a:pPr algn="r">
+              <a:lnSpc>
+                <a:spcPct val="100000"/>
+              </a:lnSpc>
+            </a:pPr>
+            <a:r>
+              <a:rPr sz="900" b="0" i="0">
+                <a:solidFill>
+                  <a:srgbClr val="5A6370"/>
+                </a:solidFill>
+                <a:latin typeface="Calibri"/>
+              </a:rPr>
+              <a:t>12</a:t>
+            </a:r>
+          </a:p>
+        </p:txBody>
+      </p:sp>
+    </p:spTree>
+  </p:cSld>
+  <p:clrMapOvr>
+    <a:masterClrMapping/>
+  </p:clrMapOvr>
+</p:sld>
+</file>
+
+<file path=ppt\slides\slide16.xml><?xml version="1.0" encoding="utf-8"?>
+<p:sld xmlns:a="http://schemas.openxmlformats.org/drawingml/2006/main" xmlns:p="http://schemas.openxmlformats.org/presentationml/2006/main" xmlns:r="http://schemas.openxmlformats.org/officeDocument/2006/relationships">
+  <p:cSld>
+    <p:spTree>
+      <p:nvGrpSpPr>
+        <p:cNvPr id="1" name=""/>
+        <p:cNvGrpSpPr/>
+        <p:nvPr/>
+      </p:nvGrpSpPr>
+      <p:grpSpPr/>
+      <p:sp>
+        <p:nvSpPr>
+          <p:cNvPr id="2" name="Rectangle 1"/>
+          <p:cNvSpPr/>
+          <p:nvPr/>
+        </p:nvSpPr>
+        <p:spPr>
+          <a:xfrm>
+            <a:off x="0" y="0"/>
+            <a:ext cx="12191695" cy="6858000"/>
+          </a:xfrm>
+          <a:prstGeom prst="rect">
+            <a:avLst/>
+          </a:prstGeom>
+          <a:solidFill>
+            <a:srgbClr val="FFFFFF"/>
+          </a:solidFill>
+          <a:ln>
+            <a:noFill/>
+          </a:ln>
+          <a:effectLst/>
+        </p:spPr>
+        <p:style>
+          <a:lnRef idx="1">
+            <a:schemeClr val="accent1"/>
+          </a:lnRef>
+          <a:fillRef idx="3">
+            <a:schemeClr val="accent1"/>
+          </a:fillRef>
+          <a:effectRef idx="2">
+            <a:schemeClr val="accent1"/>
+          </a:effectRef>
+          <a:fontRef idx="minor">
+            <a:schemeClr val="lt1"/>
+          </a:fontRef>
+        </p:style>
+        <p:txBody>
+          <a:bodyPr rtlCol="0" anchor="ctr"/>
+          <a:lstStyle/>
+          <a:p>
+            <a:pPr algn="ctr"/>
+          </a:p>
+        </p:txBody>
+      </p:sp>
+      <p:sp>
+        <p:nvSpPr>
+          <p:cNvPr id="3" name="Rectangle 2"/>
+          <p:cNvSpPr/>
+          <p:nvPr/>
+        </p:nvSpPr>
+        <p:spPr>
+          <a:xfrm>
+            <a:off x="0" y="0"/>
+            <a:ext cx="12191695" cy="1051560"/>
+          </a:xfrm>
+          <a:prstGeom prst="rect">
+            <a:avLst/>
+          </a:prstGeom>
+          <a:solidFill>
+            <a:srgbClr val="0B1F3A"/>
+          </a:solidFill>
+          <a:ln>
+            <a:noFill/>
+          </a:ln>
+          <a:effectLst/>
+        </p:spPr>
+        <p:style>
+          <a:lnRef idx="1">
+            <a:schemeClr val="accent1"/>
+          </a:lnRef>
+          <a:fillRef idx="3">
+            <a:schemeClr val="accent1"/>
+          </a:fillRef>
+          <a:effectRef idx="2">
+            <a:schemeClr val="accent1"/>
+          </a:effectRef>
+          <a:fontRef idx="minor">
+            <a:schemeClr val="lt1"/>
+          </a:fontRef>
+        </p:style>
+        <p:txBody>
+          <a:bodyPr rtlCol="0" anchor="ctr"/>
+          <a:lstStyle/>
+          <a:p>
+            <a:pPr algn="ctr"/>
+          </a:p>
+        </p:txBody>
+      </p:sp>
+      <p:sp>
+        <p:nvSpPr>
+          <p:cNvPr id="4" name="TextBox 3"/>
+          <p:cNvSpPr txBox="1"/>
+          <p:nvPr/>
+        </p:nvSpPr>
+        <p:spPr>
+          <a:xfrm>
+            <a:off x="548640" y="256032"/>
+            <a:ext cx="9601200" cy="548640"/>
+          </a:xfrm>
+          <a:prstGeom prst="rect">
+            <a:avLst/>
+          </a:prstGeom>
+          <a:noFill/>
+        </p:spPr>
+        <p:txBody>
+          <a:bodyPr wrap="square" anchor="t">
+            <a:spAutoFit/>
+          </a:bodyPr>
+          <a:lstStyle/>
+          <a:p>
+            <a:pPr algn="l">
+              <a:lnSpc>
+                <a:spcPct val="100000"/>
+              </a:lnSpc>
+            </a:pPr>
+            <a:r>
+              <a:rPr sz="2800" b="1" i="0">
+                <a:solidFill>
+                  <a:srgbClr val="FFFFFF"/>
+                </a:solidFill>
+                <a:latin typeface="Georgia"/>
+              </a:rPr>
+              <a:t>Judging Criteria</a:t>
+            </a:r>
+          </a:p>
+        </p:txBody>
+      </p:sp>
+      <p:sp>
+        <p:nvSpPr>
+          <p:cNvPr id="5" name="Card 1"/>
+          <p:cNvSpPr/>
+          <p:nvPr/>
+        </p:nvSpPr>
+        <p:spPr>
+          <a:xfrm>
+            <a:off x="731520" y="1400000"/>
+            <a:ext cx="5204307" cy="2250000"/>
+          </a:xfrm>
+          <a:prstGeom prst="roundRect">
+            <a:avLst>
+              <a:gd name="adj" fmla="val 6000"/>
+            </a:avLst>
+          </a:prstGeom>
+          <a:solidFill>
+            <a:srgbClr val="F4F6F9"/>
+          </a:solidFill>
+          <a:ln>
+            <a:noFill/>
+          </a:ln>
+          <a:effectLst/>
+        </p:spPr>
+        <p:style>
+          <a:lnRef idx="1">
+            <a:schemeClr val="accent1"/>
+          </a:lnRef>
+          <a:fillRef idx="3">
+            <a:schemeClr val="accent1"/>
+          </a:fillRef>
+          <a:effectRef idx="2">
+            <a:schemeClr val="accent1"/>
+          </a:effectRef>
+          <a:fontRef idx="minor">
+            <a:schemeClr val="lt1"/>
+          </a:fontRef>
+        </p:style>
+        <p:txBody>
+          <a:bodyPr rtlCol="0" anchor="ctr"/>
+          <a:lstStyle/>
+          <a:p>
+            <a:pPr algn="ctr"/>
+          </a:p>
+        </p:txBody>
+      </p:sp>
+      <p:sp>
+        <p:nvSpPr>
+          <p:cNvPr id="6" name="Pct 1"/>
+          <p:cNvSpPr txBox="1"/>
+          <p:nvPr/>
+        </p:nvSpPr>
+        <p:spPr>
+          <a:xfrm>
+            <a:off x="731520" y="1550000"/>
+            <a:ext cx="5204307" cy="600000"/>
+          </a:xfrm>
+          <a:prstGeom prst="rect">
+            <a:avLst/>
+          </a:prstGeom>
+          <a:noFill/>
+        </p:spPr>
+        <p:txBody>
+          <a:bodyPr wrap="square" anchor="t">
+            <a:spAutoFit/>
+          </a:bodyPr>
+          <a:lstStyle/>
+          <a:p>
+            <a:pPr algn="ctr"/>
+            <a:r>
+              <a:rPr sz="3600" b="1" i="0">
+                <a:solidFill>
+                  <a:srgbClr val="0070AD"/>
+                </a:solidFill>
+                <a:latin typeface="Calibri"/>
+              </a:rPr>
+              <a:t>30%</a:t>
+            </a:r>
+          </a:p>
+        </p:txBody>
+      </p:sp>
+      <p:sp>
+        <p:nvSpPr>
+          <p:cNvPr id="7" name="Title 1"/>
+          <p:cNvSpPr txBox="1"/>
+          <p:nvPr/>
+        </p:nvSpPr>
+        <p:spPr>
+          <a:xfrm>
+            <a:off x="731520" y="2300000"/>
+            <a:ext cx="5204307" cy="400000"/>
+          </a:xfrm>
+          <a:prstGeom prst="rect">
+            <a:avLst/>
+          </a:prstGeom>
+          <a:noFill/>
+        </p:spPr>
+        <p:txBody>
+          <a:bodyPr wrap="square" anchor="t">
+            <a:spAutoFit/>
+          </a:bodyPr>
+          <a:lstStyle/>
+          <a:p>
+            <a:pPr algn="ctr"/>
+            <a:r>
+              <a:rPr sz="1700" b="1" i="0">
+                <a:solidFill>
+                  <a:srgbClr val="1A1A1A"/>
+                </a:solidFill>
+                <a:latin typeface="Calibri"/>
+              </a:rPr>
+              <a:t>Innovation</a:t>
+            </a:r>
+          </a:p>
+        </p:txBody>
+      </p:sp>
+      <p:sp>
+        <p:nvSpPr>
+          <p:cNvPr id="8" name="Desc 1"/>
+          <p:cNvSpPr txBox="1"/>
+          <p:nvPr/>
+        </p:nvSpPr>
+        <p:spPr>
+          <a:xfrm>
+            <a:off x="1005520" y="2750000"/>
+            <a:ext cx="4656307" cy="800000"/>
+          </a:xfrm>
+          <a:prstGeom prst="rect">
+            <a:avLst/>
+          </a:prstGeom>
+          <a:noFill/>
+        </p:spPr>
+        <p:txBody>
+          <a:bodyPr wrap="square" anchor="t">
+            <a:spAutoFit/>
+          </a:bodyPr>
+          <a:lstStyle/>
+          <a:p>
+            <a:pPr algn="ctr">
+              <a:lnSpc>
+                <a:spcPct val="115000"/>
+              </a:lnSpc>
+            </a:pPr>
+            <a:r>
+              <a:rPr sz="1200" b="0" i="0">
+                <a:solidFill>
+                  <a:srgbClr val="5A6370"/>
+                </a:solidFill>
+                <a:latin typeface="Calibri"/>
+              </a:rPr>
+              <a:t>One governed agent spanning structured, unstructured, and meta (data-quality) data — not three disconnected demos.</a:t>
+            </a:r>
+          </a:p>
+        </p:txBody>
+      </p:sp>
+      <p:sp>
+        <p:nvSpPr>
+          <p:cNvPr id="9" name="Card 2"/>
+          <p:cNvSpPr/>
+          <p:nvPr/>
+        </p:nvSpPr>
+        <p:spPr>
+          <a:xfrm>
+            <a:off x="6255867" y="1400000"/>
+            <a:ext cx="5204307" cy="2250000"/>
+          </a:xfrm>
+          <a:prstGeom prst="roundRect">
+            <a:avLst>
+              <a:gd name="adj" fmla="val 6000"/>
+            </a:avLst>
+          </a:prstGeom>
+          <a:solidFill>
+            <a:srgbClr val="F4F6F9"/>
+          </a:solidFill>
+          <a:ln>
+            <a:noFill/>
+          </a:ln>
+          <a:effectLst/>
+        </p:spPr>
+        <p:style>
+          <a:lnRef idx="1">
+            <a:schemeClr val="accent1"/>
+          </a:lnRef>
+          <a:fillRef idx="3">
+            <a:schemeClr val="accent1"/>
+          </a:fillRef>
+          <a:effectRef idx="2">
+            <a:schemeClr val="accent1"/>
+          </a:effectRef>
+          <a:fontRef idx="minor">
+            <a:schemeClr val="lt1"/>
+          </a:fontRef>
+        </p:style>
+        <p:txBody>
+          <a:bodyPr rtlCol="0" anchor="ctr"/>
+          <a:lstStyle/>
+          <a:p>
+            <a:pPr algn="ctr"/>
+          </a:p>
+        </p:txBody>
+      </p:sp>
+      <p:sp>
+        <p:nvSpPr>
+          <p:cNvPr id="10" name="Pct 2"/>
+          <p:cNvSpPr txBox="1"/>
+          <p:nvPr/>
+        </p:nvSpPr>
+        <p:spPr>
+          <a:xfrm>
+            <a:off x="6255867" y="1550000"/>
+            <a:ext cx="5204307" cy="600000"/>
+          </a:xfrm>
+          <a:prstGeom prst="rect">
+            <a:avLst/>
+          </a:prstGeom>
+          <a:noFill/>
+        </p:spPr>
+        <p:txBody>
+          <a:bodyPr wrap="square" anchor="t">
+            <a:spAutoFit/>
+          </a:bodyPr>
+          <a:lstStyle/>
+          <a:p>
+            <a:pPr algn="ctr"/>
+            <a:r>
+              <a:rPr sz="3600" b="1" i="0">
+                <a:solidFill>
+                  <a:srgbClr val="0070AD"/>
+                </a:solidFill>
+                <a:latin typeface="Calibri"/>
+              </a:rPr>
+              <a:t>25%</a:t>
+            </a:r>
+          </a:p>
+        </p:txBody>
+      </p:sp>
+      <p:sp>
+        <p:nvSpPr>
+          <p:cNvPr id="11" name="Title 2"/>
+          <p:cNvSpPr txBox="1"/>
+          <p:nvPr/>
+        </p:nvSpPr>
+        <p:spPr>
+          <a:xfrm>
+            <a:off x="6255867" y="2300000"/>
+            <a:ext cx="5204307" cy="400000"/>
+          </a:xfrm>
+          <a:prstGeom prst="rect">
+            <a:avLst/>
+          </a:prstGeom>
+          <a:noFill/>
+        </p:spPr>
+        <p:txBody>
+          <a:bodyPr wrap="square" anchor="t">
+            <a:spAutoFit/>
+          </a:bodyPr>
+          <a:lstStyle/>
+          <a:p>
+            <a:pPr algn="ctr"/>
+            <a:r>
+              <a:rPr sz="1700" b="1" i="0">
+                <a:solidFill>
+                  <a:srgbClr val="1A1A1A"/>
+                </a:solidFill>
+                <a:latin typeface="Calibri"/>
+              </a:rPr>
+              <a:t>Technical Excellence</a:t>
+            </a:r>
+          </a:p>
+        </p:txBody>
+      </p:sp>
+      <p:sp>
+        <p:nvSpPr>
+          <p:cNvPr id="12" name="Desc 2"/>
+          <p:cNvSpPr txBox="1"/>
+          <p:nvPr/>
+        </p:nvSpPr>
+        <p:spPr>
+          <a:xfrm>
+            <a:off x="6529867" y="2750000"/>
+            <a:ext cx="4656307" cy="800000"/>
+          </a:xfrm>
+          <a:prstGeom prst="rect">
+            <a:avLst/>
+          </a:prstGeom>
+          <a:noFill/>
+        </p:spPr>
+        <p:txBody>
+          <a:bodyPr wrap="square" anchor="t">
+            <a:spAutoFit/>
+          </a:bodyPr>
+          <a:lstStyle/>
+          <a:p>
+            <a:pPr algn="ctr">
+              <a:lnSpc>
+                <a:spcPct val="115000"/>
+              </a:lnSpc>
+            </a:pPr>
+            <a:r>
+              <a:rPr sz="1200" b="0" i="0">
+                <a:solidFill>
+                  <a:srgbClr val="5A6370"/>
+                </a:solidFill>
+                <a:latin typeface="Calibri"/>
+              </a:rPr>
+              <a:t>Native SEMANTIC VIEW, CORTEX SEARCH SERVICE, and AGENT objects — no hand-rolled RAG or orchestration code.</a:t>
+            </a:r>
+          </a:p>
+        </p:txBody>
+      </p:sp>
+      <p:sp>
+        <p:nvSpPr>
+          <p:cNvPr id="13" name="Card 3"/>
+          <p:cNvSpPr/>
+          <p:nvPr/>
+        </p:nvSpPr>
+        <p:spPr>
+          <a:xfrm>
+            <a:off x="731520" y="3950000"/>
+            <a:ext cx="5204307" cy="2250000"/>
+          </a:xfrm>
+          <a:prstGeom prst="roundRect">
+            <a:avLst>
+              <a:gd name="adj" fmla="val 6000"/>
+            </a:avLst>
+          </a:prstGeom>
+          <a:solidFill>
+            <a:srgbClr val="F4F6F9"/>
+          </a:solidFill>
+          <a:ln>
+            <a:noFill/>
+          </a:ln>
+          <a:effectLst/>
+        </p:spPr>
+        <p:style>
+          <a:lnRef idx="1">
+            <a:schemeClr val="accent1"/>
+          </a:lnRef>
+          <a:fillRef idx="3">
+            <a:schemeClr val="accent1"/>
+          </a:fillRef>
+          <a:effectRef idx="2">
+            <a:schemeClr val="accent1"/>
+          </a:effectRef>
+          <a:fontRef idx="minor">
+            <a:schemeClr val="lt1"/>
+          </a:fontRef>
+        </p:style>
+        <p:txBody>
+          <a:bodyPr rtlCol="0" anchor="ctr"/>
+          <a:lstStyle/>
+          <a:p>
+            <a:pPr algn="ctr"/>
+          </a:p>
+        </p:txBody>
+      </p:sp>
+      <p:sp>
+        <p:nvSpPr>
+          <p:cNvPr id="14" name="Pct 3"/>
+          <p:cNvSpPr txBox="1"/>
+          <p:nvPr/>
+        </p:nvSpPr>
+        <p:spPr>
+          <a:xfrm>
+            <a:off x="731520" y="4100000"/>
+            <a:ext cx="5204307" cy="600000"/>
+          </a:xfrm>
+          <a:prstGeom prst="rect">
+            <a:avLst/>
+          </a:prstGeom>
+          <a:noFill/>
+        </p:spPr>
+        <p:txBody>
+          <a:bodyPr wrap="square" anchor="t">
+            <a:spAutoFit/>
+          </a:bodyPr>
+          <a:lstStyle/>
+          <a:p>
+            <a:pPr algn="ctr"/>
+            <a:r>
+              <a:rPr sz="3600" b="1" i="0">
+                <a:solidFill>
+                  <a:srgbClr val="0070AD"/>
+                </a:solidFill>
+                <a:latin typeface="Calibri"/>
+              </a:rPr>
+              <a:t>25%</a:t>
+            </a:r>
+          </a:p>
+        </p:txBody>
+      </p:sp>
+      <p:sp>
+        <p:nvSpPr>
+          <p:cNvPr id="15" name="Title 3"/>
+          <p:cNvSpPr txBox="1"/>
+          <p:nvPr/>
+        </p:nvSpPr>
+        <p:spPr>
+          <a:xfrm>
+            <a:off x="731520" y="4850000"/>
+            <a:ext cx="5204307" cy="400000"/>
+          </a:xfrm>
+          <a:prstGeom prst="rect">
+            <a:avLst/>
+          </a:prstGeom>
+          <a:noFill/>
+        </p:spPr>
+        <p:txBody>
+          <a:bodyPr wrap="square" anchor="t">
+            <a:spAutoFit/>
+          </a:bodyPr>
+          <a:lstStyle/>
+          <a:p>
+            <a:pPr algn="ctr"/>
+            <a:r>
+              <a:rPr sz="1700" b="1" i="0">
+                <a:solidFill>
+                  <a:srgbClr val="1A1A1A"/>
+                </a:solidFill>
+                <a:latin typeface="Calibri"/>
+              </a:rPr>
+              <a:t>Business Value</a:t>
+            </a:r>
+          </a:p>
+        </p:txBody>
+      </p:sp>
+      <p:sp>
+        <p:nvSpPr>
+          <p:cNvPr id="16" name="Desc 3"/>
+          <p:cNvSpPr txBox="1"/>
+          <p:nvPr/>
+        </p:nvSpPr>
+        <p:spPr>
+          <a:xfrm>
+            <a:off x="1005520" y="5300000"/>
+            <a:ext cx="4656307" cy="800000"/>
+          </a:xfrm>
+          <a:prstGeom prst="rect">
+            <a:avLst/>
+          </a:prstGeom>
+          <a:noFill/>
+        </p:spPr>
+        <p:txBody>
+          <a:bodyPr wrap="square" anchor="t">
+            <a:spAutoFit/>
+          </a:bodyPr>
+          <a:lstStyle/>
+          <a:p>
+            <a:pPr algn="ctr">
+              <a:lnSpc>
+                <a:spcPct val="115000"/>
+              </a:lnSpc>
+            </a:pPr>
+            <a:r>
+              <a:rPr sz="1200" b="0" i="0">
+                <a:solidFill>
+                  <a:srgbClr val="5A6370"/>
+                </a:solidFill>
+                <a:latin typeface="Calibri"/>
+              </a:rPr>
+              <a:t>Collapses three specialist workflows (SQL analyst, document reviewer, DQ engineer) into one self-service chat experience.</a:t>
+            </a:r>
+          </a:p>
+        </p:txBody>
+      </p:sp>
+      <p:sp>
+        <p:nvSpPr>
+          <p:cNvPr id="17" name="Card 4"/>
+          <p:cNvSpPr/>
+          <p:nvPr/>
+        </p:nvSpPr>
+        <p:spPr>
+          <a:xfrm>
+            <a:off x="6255867" y="3950000"/>
+            <a:ext cx="5204307" cy="2250000"/>
+          </a:xfrm>
+          <a:prstGeom prst="roundRect">
+            <a:avLst>
+              <a:gd name="adj" fmla="val 6000"/>
+            </a:avLst>
+          </a:prstGeom>
+          <a:solidFill>
+            <a:srgbClr val="F4F6F9"/>
+          </a:solidFill>
+          <a:ln>
+            <a:noFill/>
+          </a:ln>
+          <a:effectLst/>
+        </p:spPr>
+        <p:style>
+          <a:lnRef idx="1">
+            <a:schemeClr val="accent1"/>
+          </a:lnRef>
+          <a:fillRef idx="3">
+            <a:schemeClr val="accent1"/>
+          </a:fillRef>
+          <a:effectRef idx="2">
+            <a:schemeClr val="accent1"/>
+          </a:effectRef>
+          <a:fontRef idx="minor">
+            <a:schemeClr val="lt1"/>
+          </a:fontRef>
+        </p:style>
+        <p:txBody>
+          <a:bodyPr rtlCol="0" anchor="ctr"/>
+          <a:lstStyle/>
+          <a:p>
+            <a:pPr algn="ctr"/>
+          </a:p>
+        </p:txBody>
+      </p:sp>
+      <p:sp>
+        <p:nvSpPr>
+          <p:cNvPr id="18" name="Pct 4"/>
+          <p:cNvSpPr txBox="1"/>
+          <p:nvPr/>
+        </p:nvSpPr>
+        <p:spPr>
+          <a:xfrm>
+            <a:off x="6255867" y="4100000"/>
+            <a:ext cx="5204307" cy="600000"/>
+          </a:xfrm>
+          <a:prstGeom prst="rect">
+            <a:avLst/>
+          </a:prstGeom>
+          <a:noFill/>
+        </p:spPr>
+        <p:txBody>
+          <a:bodyPr wrap="square" anchor="t">
+            <a:spAutoFit/>
+          </a:bodyPr>
+          <a:lstStyle/>
+          <a:p>
+            <a:pPr algn="ctr"/>
+            <a:r>
+              <a:rPr sz="3600" b="1" i="0">
+                <a:solidFill>
+                  <a:srgbClr val="0070AD"/>
+                </a:solidFill>
+                <a:latin typeface="Calibri"/>
+              </a:rPr>
+              <a:t>20%</a:t>
+            </a:r>
+          </a:p>
+        </p:txBody>
+      </p:sp>
+      <p:sp>
+        <p:nvSpPr>
+          <p:cNvPr id="19" name="Title 4"/>
+          <p:cNvSpPr txBox="1"/>
+          <p:nvPr/>
+        </p:nvSpPr>
+        <p:spPr>
+          <a:xfrm>
+            <a:off x="6255867" y="4850000"/>
+            <a:ext cx="5204307" cy="400000"/>
+          </a:xfrm>
+          <a:prstGeom prst="rect">
+            <a:avLst/>
+          </a:prstGeom>
+          <a:noFill/>
+        </p:spPr>
+        <p:txBody>
+          <a:bodyPr wrap="square" anchor="t">
+            <a:spAutoFit/>
+          </a:bodyPr>
+          <a:lstStyle/>
+          <a:p>
+            <a:pPr algn="ctr"/>
+            <a:r>
+              <a:rPr sz="1700" b="1" i="0">
+                <a:solidFill>
+                  <a:srgbClr val="1A1A1A"/>
+                </a:solidFill>
+                <a:latin typeface="Calibri"/>
+              </a:rPr>
+              <a:t>User Experience</a:t>
+            </a:r>
+          </a:p>
+        </p:txBody>
+      </p:sp>
+      <p:sp>
+        <p:nvSpPr>
+          <p:cNvPr id="20" name="Desc 4"/>
+          <p:cNvSpPr txBox="1"/>
+          <p:nvPr/>
+        </p:nvSpPr>
+        <p:spPr>
+          <a:xfrm>
+            <a:off x="6529867" y="5300000"/>
+            <a:ext cx="4656307" cy="800000"/>
+          </a:xfrm>
+          <a:prstGeom prst="rect">
+            <a:avLst/>
+          </a:prstGeom>
+          <a:noFill/>
+        </p:spPr>
+        <p:txBody>
+          <a:bodyPr wrap="square" anchor="t">
+            <a:spAutoFit/>
+          </a:bodyPr>
+          <a:lstStyle/>
+          <a:p>
+            <a:pPr algn="ctr">
+              <a:lnSpc>
+                <a:spcPct val="115000"/>
+              </a:lnSpc>
+            </a:pPr>
+            <a:r>
+              <a:rPr sz="1200" b="0" i="0">
+                <a:solidFill>
+                  <a:srgbClr val="5A6370"/>
+                </a:solidFill>
+                <a:latin typeface="Calibri"/>
+              </a:rPr>
+              <a:t>One chat box; every answer is explainable — SQL shown, sources cited — so business users can trust and verify it.</a:t>
+            </a:r>
+          </a:p>
+        </p:txBody>
+      </p:sp>
+      <p:sp>
+        <p:nvSpPr>
+          <p:cNvPr id="21" name="TextBox 20"/>
+          <p:cNvSpPr txBox="1"/>
+          <p:nvPr/>
+        </p:nvSpPr>
+        <p:spPr>
+          <a:xfrm>
+            <a:off x="457200" y="6473952"/>
+            <a:ext cx="5486400" cy="320040"/>
+          </a:xfrm>
+          <a:prstGeom prst="rect">
+            <a:avLst/>
+          </a:prstGeom>
+          <a:noFill/>
+        </p:spPr>
+        <p:txBody>
+          <a:bodyPr wrap="square" anchor="t">
+            <a:spAutoFit/>
+          </a:bodyPr>
+          <a:lstStyle/>
+          <a:p>
+            <a:pPr algn="l">
+              <a:lnSpc>
+                <a:spcPct val="100000"/>
+              </a:lnSpc>
+            </a:pPr>
+            <a:r>
+              <a:rPr sz="900" b="0" i="1">
+                <a:solidFill>
+                  <a:srgbClr val="5A6370"/>
+                </a:solidFill>
+                <a:latin typeface="Calibri"/>
+              </a:rPr>
+              <a:t>Unified Enterprise AI Agents Platform  |  Capgemini x Snowflake Hackathon</a:t>
+            </a:r>
+          </a:p>
+        </p:txBody>
+      </p:sp>
+      <p:sp>
+        <p:nvSpPr>
+          <p:cNvPr id="22" name="TextBox 21"/>
+          <p:cNvSpPr txBox="1"/>
+          <p:nvPr/>
+        </p:nvSpPr>
+        <p:spPr>
+          <a:xfrm>
+            <a:off x="11247120" y="6473952"/>
+            <a:ext cx="731520" cy="320040"/>
+          </a:xfrm>
+          <a:prstGeom prst="rect">
+            <a:avLst/>
+          </a:prstGeom>
+          <a:noFill/>
+        </p:spPr>
+        <p:txBody>
+          <a:bodyPr wrap="square" anchor="t">
+            <a:spAutoFit/>
+          </a:bodyPr>
+          <a:lstStyle/>
+          <a:p>
+            <a:pPr algn="r">
+              <a:lnSpc>
+                <a:spcPct val="100000"/>
+              </a:lnSpc>
+            </a:pPr>
+            <a:r>
+              <a:rPr sz="900" b="0" i="0">
+                <a:solidFill>
+                  <a:srgbClr val="5A6370"/>
+                </a:solidFill>
+                <a:latin typeface="Calibri"/>
+              </a:rPr>
+              <a:t>13</a:t>
+            </a:r>
+          </a:p>
+        </p:txBody>
+      </p:sp>
+    </p:spTree>
+  </p:cSld>
+  <p:clrMapOvr>
+    <a:masterClrMapping/>
+  </p:clrMapOvr>
+</p:sld>
+</file>
+
 <file path=ppt\slides\slide2.xml><?xml version="1.0" encoding="utf-8"?>
 <p:sld xmlns:a="http://schemas.openxmlformats.org/drawingml/2006/main" xmlns:p="http://schemas.openxmlformats.org/presentationml/2006/main" xmlns:r="http://schemas.openxmlformats.org/officeDocument/2006/relationships">
   <p:cSld>
@@ -5818,6 +6973,45 @@
                 <a:latin typeface="Georgia"/>
               </a:rPr>
               <a:t>The Problem</a:t>
+            </a:r>
+          </a:p>
+        </p:txBody>
+      </p:sp>
+      <p:sp>
+        <p:nvSpPr>
+          <p:cNvPr id="24" name="TextBox 23"/>
+          <p:cNvSpPr txBox="1"/>
+          <p:nvPr/>
+        </p:nvSpPr>
+        <p:spPr>
+          <a:xfrm>
+            <a:off x="731520" y="850000"/>
+            <a:ext cx="10698480" cy="400000"/>
+          </a:xfrm>
+          <a:prstGeom prst="rect">
+            <a:avLst/>
+          </a:prstGeom>
+          <a:noFill/>
+        </p:spPr>
+        <p:txBody>
+          <a:bodyPr wrap="square" anchor="t">
+            <a:spAutoFit/>
+          </a:bodyPr>
+          <a:lstStyle/>
+          <a:p>
+            <a:pPr algn="l">
+              <a:lnSpc>
+                <a:spcPct val="100000"/>
+              </a:lnSpc>
+            </a:pPr>
+            <a:r>
+              <a:rPr sz="2000" b="1" i="0">
+                <a:solidFill>
+                  <a:srgbClr val="0070AD"/>
+                </a:solidFill>
+                <a:latin typeface="Calibri"/>
+              </a:rPr>
+              <a:t>One question. Three specialists. One bottleneck.</a:t>
             </a:r>
           </a:p>
         </p:txBody>

</xml_diff>

<commit_message>
Rebrand pptx and PDF with Ansura name
- Title slide, footers, and the "Unified" callout in the pptx now read
  Ansura, with "Unified Enterprise AI Agents Platform" kept as tagline.
- Architecture PDF title/header/footer updated to Ansura on all 3 pages.

Co-Authored-By: Claude Sonnet 5 <noreply@anthropic.com>
</commit_message>
<xml_diff>
--- a/docs/Unified_Enterprise_AI_Agents_Platform.pptx
+++ b/docs/Unified_Enterprise_AI_Agents_Platform.pptx
@@ -3289,7 +3289,7 @@
                 </a:solidFill>
                 <a:latin typeface="Georgia"/>
               </a:rPr>
-              <a:t>Unified Enterprise AI Agents Platform</a:t>
+              <a:t>Ansura</a:t>
             </a:r>
           </a:p>
         </p:txBody>
@@ -3311,6 +3311,17 @@
           <a:noFill/>
         </p:spPr>
         <p:txBody>
+          <a:p>
+            <a:r>
+              <a:rPr b="1" sz="1700">
+                <a:solidFill>
+                  <a:srgbClr val="29B5E8"/>
+                </a:solidFill>
+                <a:latin typeface="Calibri"/>
+              </a:rPr>
+              <a:t>Unified Enterprise AI Agents Platform</a:t>
+            </a:r>
+          </a:p>
           <a:bodyPr wrap="square" anchor="t">
             <a:spAutoFit/>
           </a:bodyPr>
@@ -3666,7 +3677,7 @@
                 </a:solidFill>
                 <a:latin typeface="Calibri"/>
               </a:rPr>
-              <a:t>This is the “Unified” in the project name — not three separate demos, but one agent</a:t>
+              <a:t>This is Ansura — not three separate demos, but one agent</a:t>
             </a:r>
           </a:p>
           <a:p>
@@ -4241,7 +4252,7 @@
                 </a:solidFill>
                 <a:latin typeface="Calibri"/>
               </a:rPr>
-              <a:t>Unified Enterprise AI Agents Platform  |  Capgemini × Snowflake Hackathon</a:t>
+              <a:t>Ansura  |  Capgemini × Snowflake Hackathon</a:t>
             </a:r>
           </a:p>
         </p:txBody>
@@ -4828,7 +4839,7 @@
                 </a:solidFill>
                 <a:latin typeface="Calibri"/>
               </a:rPr>
-              <a:t>Unified Enterprise AI Agents Platform  |  Capgemini × Snowflake Hackathon</a:t>
+              <a:t>Ansura  |  Capgemini × Snowflake Hackathon</a:t>
             </a:r>
           </a:p>
         </p:txBody>
@@ -4868,6 +4879,905 @@
                 <a:latin typeface="Calibri"/>
               </a:rPr>
               <a:t>11</a:t>
+            </a:r>
+          </a:p>
+        </p:txBody>
+      </p:sp>
+    </p:spTree>
+  </p:cSld>
+  <p:clrMapOvr>
+    <a:masterClrMapping/>
+  </p:clrMapOvr>
+</p:sld>
+</file>
+
+<file path=ppt/slides/slide12.xml><?xml version="1.0" encoding="utf-8"?>
+<p:sld xmlns:a="http://schemas.openxmlformats.org/drawingml/2006/main" xmlns:p="http://schemas.openxmlformats.org/presentationml/2006/main" xmlns:r="http://schemas.openxmlformats.org/officeDocument/2006/relationships">
+  <p:cSld>
+    <p:spTree>
+      <p:nvGrpSpPr>
+        <p:cNvPr id="1" name=""/>
+        <p:cNvGrpSpPr/>
+        <p:nvPr/>
+      </p:nvGrpSpPr>
+      <p:grpSpPr/>
+      <p:sp>
+        <p:nvSpPr>
+          <p:cNvPr id="2" name="Rectangle 1"/>
+          <p:cNvSpPr/>
+          <p:nvPr/>
+        </p:nvSpPr>
+        <p:spPr>
+          <a:xfrm>
+            <a:off x="0" y="0"/>
+            <a:ext cx="12191695" cy="6858000"/>
+          </a:xfrm>
+          <a:prstGeom prst="rect">
+            <a:avLst/>
+          </a:prstGeom>
+          <a:solidFill>
+            <a:srgbClr val="FFFFFF"/>
+          </a:solidFill>
+          <a:ln>
+            <a:noFill/>
+          </a:ln>
+          <a:effectLst/>
+        </p:spPr>
+        <p:style>
+          <a:lnRef idx="1">
+            <a:schemeClr val="accent1"/>
+          </a:lnRef>
+          <a:fillRef idx="3">
+            <a:schemeClr val="accent1"/>
+          </a:fillRef>
+          <a:effectRef idx="2">
+            <a:schemeClr val="accent1"/>
+          </a:effectRef>
+          <a:fontRef idx="minor">
+            <a:schemeClr val="lt1"/>
+          </a:fontRef>
+        </p:style>
+        <p:txBody>
+          <a:bodyPr rtlCol="0" anchor="ctr"/>
+          <a:lstStyle/>
+          <a:p>
+            <a:pPr algn="ctr"/>
+          </a:p>
+        </p:txBody>
+      </p:sp>
+      <p:sp>
+        <p:nvSpPr>
+          <p:cNvPr id="3" name="Rectangle 2"/>
+          <p:cNvSpPr/>
+          <p:nvPr/>
+        </p:nvSpPr>
+        <p:spPr>
+          <a:xfrm>
+            <a:off x="0" y="0"/>
+            <a:ext cx="12191695" cy="1051560"/>
+          </a:xfrm>
+          <a:prstGeom prst="rect">
+            <a:avLst/>
+          </a:prstGeom>
+          <a:solidFill>
+            <a:srgbClr val="0B1F3A"/>
+          </a:solidFill>
+          <a:ln>
+            <a:noFill/>
+          </a:ln>
+          <a:effectLst/>
+        </p:spPr>
+        <p:style>
+          <a:lnRef idx="1">
+            <a:schemeClr val="accent1"/>
+          </a:lnRef>
+          <a:fillRef idx="3">
+            <a:schemeClr val="accent1"/>
+          </a:fillRef>
+          <a:effectRef idx="2">
+            <a:schemeClr val="accent1"/>
+          </a:effectRef>
+          <a:fontRef idx="minor">
+            <a:schemeClr val="lt1"/>
+          </a:fontRef>
+        </p:style>
+        <p:txBody>
+          <a:bodyPr rtlCol="0" anchor="ctr"/>
+          <a:lstStyle/>
+          <a:p>
+            <a:pPr algn="ctr"/>
+          </a:p>
+        </p:txBody>
+      </p:sp>
+      <p:sp>
+        <p:nvSpPr>
+          <p:cNvPr id="4" name="TextBox 3"/>
+          <p:cNvSpPr txBox="1"/>
+          <p:nvPr/>
+        </p:nvSpPr>
+        <p:spPr>
+          <a:xfrm>
+            <a:off x="548640" y="256032"/>
+            <a:ext cx="7315200" cy="548640"/>
+          </a:xfrm>
+          <a:prstGeom prst="rect">
+            <a:avLst/>
+          </a:prstGeom>
+          <a:noFill/>
+        </p:spPr>
+        <p:txBody>
+          <a:bodyPr wrap="square" anchor="t">
+            <a:spAutoFit/>
+          </a:bodyPr>
+          <a:lstStyle/>
+          <a:p>
+            <a:pPr algn="l">
+              <a:lnSpc>
+                <a:spcPct val="100000"/>
+              </a:lnSpc>
+            </a:pPr>
+            <a:r>
+              <a:rPr sz="3000" b="1" i="0">
+                <a:solidFill>
+                  <a:srgbClr val="FFFFFF"/>
+                </a:solidFill>
+                <a:latin typeface="Georgia"/>
+              </a:rPr>
+              <a:t>Benefits</a:t>
+            </a:r>
+          </a:p>
+        </p:txBody>
+      </p:sp>
+      <p:sp>
+        <p:nvSpPr>
+          <p:cNvPr id="20" name="Benefit Card 1"/>
+          <p:cNvSpPr/>
+          <p:nvPr/>
+        </p:nvSpPr>
+        <p:spPr>
+          <a:xfrm>
+            <a:off x="731520" y="1417320"/>
+            <a:ext cx="5212080" cy="1920240"/>
+          </a:xfrm>
+          <a:prstGeom prst="roundRect">
+            <a:avLst>
+              <a:gd name="adj" fmla="val 8000"/>
+            </a:avLst>
+          </a:prstGeom>
+          <a:solidFill>
+            <a:srgbClr val="F4F6F9"/>
+          </a:solidFill>
+          <a:ln>
+            <a:noFill/>
+          </a:ln>
+          <a:effectLst/>
+        </p:spPr>
+        <p:style>
+          <a:lnRef idx="1">
+            <a:schemeClr val="accent1"/>
+          </a:lnRef>
+          <a:fillRef idx="3">
+            <a:schemeClr val="accent1"/>
+          </a:fillRef>
+          <a:effectRef idx="2">
+            <a:schemeClr val="accent1"/>
+          </a:effectRef>
+          <a:fontRef idx="minor">
+            <a:schemeClr val="lt1"/>
+          </a:fontRef>
+        </p:style>
+        <p:txBody>
+          <a:bodyPr wrap="square" lIns="0" tIns="0" rIns="0" bIns="0" anchor="t"/>
+          <a:lstStyle/>
+          <a:p>
+            <a:pPr algn="l"/>
+          </a:p>
+        </p:txBody>
+      </p:sp>
+      <p:sp>
+        <p:nvSpPr>
+          <p:cNvPr id="21" name="Benefit Num 1"/>
+          <p:cNvSpPr/>
+          <p:nvPr/>
+        </p:nvSpPr>
+        <p:spPr>
+          <a:xfrm>
+            <a:off x="1097280" y="1828800"/>
+            <a:ext cx="731520" cy="731520"/>
+          </a:xfrm>
+          <a:prstGeom prst="ellipse">
+            <a:avLst/>
+          </a:prstGeom>
+          <a:solidFill>
+            <a:srgbClr val="0B1F3A"/>
+          </a:solidFill>
+          <a:ln>
+            <a:noFill/>
+          </a:ln>
+          <a:effectLst/>
+        </p:spPr>
+        <p:style>
+          <a:lnRef idx="1">
+            <a:schemeClr val="accent1"/>
+          </a:lnRef>
+          <a:fillRef idx="3">
+            <a:schemeClr val="accent1"/>
+          </a:fillRef>
+          <a:effectRef idx="2">
+            <a:schemeClr val="accent1"/>
+          </a:effectRef>
+          <a:fontRef idx="minor">
+            <a:schemeClr val="lt1"/>
+          </a:fontRef>
+        </p:style>
+        <p:txBody>
+          <a:bodyPr wrap="square" lIns="0" tIns="0" rIns="0" bIns="0" anchor="ctr"/>
+          <a:lstStyle/>
+          <a:p>
+            <a:pPr algn="ctr"/>
+            <a:r>
+              <a:rPr lang="en-US" sz="2400" b="1">
+                <a:solidFill>
+                  <a:srgbClr val="FFFFFF"/>
+                </a:solidFill>
+                <a:latin typeface="Calibri"/>
+              </a:rPr>
+              <a:t>1</a:t>
+            </a:r>
+          </a:p>
+        </p:txBody>
+      </p:sp>
+      <p:sp>
+        <p:nvSpPr>
+          <p:cNvPr id="22" name="Benefit Title 1"/>
+          <p:cNvSpPr txBox="1"/>
+          <p:nvPr/>
+        </p:nvSpPr>
+        <p:spPr>
+          <a:xfrm>
+            <a:off x="2103120" y="1828800"/>
+            <a:ext cx="3474720" cy="411480"/>
+          </a:xfrm>
+          <a:prstGeom prst="rect">
+            <a:avLst/>
+          </a:prstGeom>
+          <a:noFill/>
+        </p:spPr>
+        <p:txBody>
+          <a:bodyPr wrap="square" lIns="0" tIns="0" rIns="0" bIns="0" anchor="t"/>
+          <a:lstStyle/>
+          <a:p>
+            <a:pPr algn="l"/>
+            <a:r>
+              <a:rPr lang="en-US" sz="1800" b="1">
+                <a:solidFill>
+                  <a:srgbClr val="0B1F3A"/>
+                </a:solidFill>
+                <a:latin typeface="Calibri"/>
+              </a:rPr>
+              <a:t>Faster answers</a:t>
+            </a:r>
+          </a:p>
+        </p:txBody>
+      </p:sp>
+      <p:sp>
+        <p:nvSpPr>
+          <p:cNvPr id="23" name="Benefit Desc 1"/>
+          <p:cNvSpPr txBox="1"/>
+          <p:nvPr/>
+        </p:nvSpPr>
+        <p:spPr>
+          <a:xfrm>
+            <a:off x="2103120" y="2286000"/>
+            <a:ext cx="3474720" cy="822960"/>
+          </a:xfrm>
+          <a:prstGeom prst="rect">
+            <a:avLst/>
+          </a:prstGeom>
+          <a:noFill/>
+        </p:spPr>
+        <p:txBody>
+          <a:bodyPr wrap="square" lIns="0" tIns="0" rIns="0" bIns="0" anchor="t"/>
+          <a:lstStyle/>
+          <a:p>
+            <a:pPr algn="l">
+              <a:lnSpc>
+                <a:spcPct val="115000"/>
+              </a:lnSpc>
+            </a:pPr>
+            <a:r>
+              <a:rPr lang="en-US" sz="1400" b="0">
+                <a:solidFill>
+                  <a:srgbClr val="5A6370"/>
+                </a:solidFill>
+                <a:latin typeface="Calibri"/>
+              </a:rPr>
+              <a:t>Hours of waiting on a specialist collapse into a single conversation.</a:t>
+            </a:r>
+          </a:p>
+        </p:txBody>
+      </p:sp>
+      <p:sp>
+        <p:nvSpPr>
+          <p:cNvPr id="24" name="Benefit Card 2"/>
+          <p:cNvSpPr/>
+          <p:nvPr/>
+        </p:nvSpPr>
+        <p:spPr>
+          <a:xfrm>
+            <a:off x="6263640" y="1417320"/>
+            <a:ext cx="5212080" cy="1920240"/>
+          </a:xfrm>
+          <a:prstGeom prst="roundRect">
+            <a:avLst>
+              <a:gd name="adj" fmla="val 8000"/>
+            </a:avLst>
+          </a:prstGeom>
+          <a:solidFill>
+            <a:srgbClr val="F4F6F9"/>
+          </a:solidFill>
+          <a:ln>
+            <a:noFill/>
+          </a:ln>
+          <a:effectLst/>
+        </p:spPr>
+        <p:style>
+          <a:lnRef idx="1">
+            <a:schemeClr val="accent1"/>
+          </a:lnRef>
+          <a:fillRef idx="3">
+            <a:schemeClr val="accent1"/>
+          </a:fillRef>
+          <a:effectRef idx="2">
+            <a:schemeClr val="accent1"/>
+          </a:effectRef>
+          <a:fontRef idx="minor">
+            <a:schemeClr val="lt1"/>
+          </a:fontRef>
+        </p:style>
+        <p:txBody>
+          <a:bodyPr wrap="square" lIns="0" tIns="0" rIns="0" bIns="0" anchor="t"/>
+          <a:lstStyle/>
+          <a:p>
+            <a:pPr algn="l"/>
+          </a:p>
+        </p:txBody>
+      </p:sp>
+      <p:sp>
+        <p:nvSpPr>
+          <p:cNvPr id="25" name="Benefit Num 2"/>
+          <p:cNvSpPr/>
+          <p:nvPr/>
+        </p:nvSpPr>
+        <p:spPr>
+          <a:xfrm>
+            <a:off x="6629400" y="1828800"/>
+            <a:ext cx="731520" cy="731520"/>
+          </a:xfrm>
+          <a:prstGeom prst="ellipse">
+            <a:avLst/>
+          </a:prstGeom>
+          <a:solidFill>
+            <a:srgbClr val="0B1F3A"/>
+          </a:solidFill>
+          <a:ln>
+            <a:noFill/>
+          </a:ln>
+          <a:effectLst/>
+        </p:spPr>
+        <p:style>
+          <a:lnRef idx="1">
+            <a:schemeClr val="accent1"/>
+          </a:lnRef>
+          <a:fillRef idx="3">
+            <a:schemeClr val="accent1"/>
+          </a:fillRef>
+          <a:effectRef idx="2">
+            <a:schemeClr val="accent1"/>
+          </a:effectRef>
+          <a:fontRef idx="minor">
+            <a:schemeClr val="lt1"/>
+          </a:fontRef>
+        </p:style>
+        <p:txBody>
+          <a:bodyPr wrap="square" lIns="0" tIns="0" rIns="0" bIns="0" anchor="ctr"/>
+          <a:lstStyle/>
+          <a:p>
+            <a:pPr algn="ctr"/>
+            <a:r>
+              <a:rPr lang="en-US" sz="2400" b="1">
+                <a:solidFill>
+                  <a:srgbClr val="FFFFFF"/>
+                </a:solidFill>
+                <a:latin typeface="Calibri"/>
+              </a:rPr>
+              <a:t>2</a:t>
+            </a:r>
+          </a:p>
+        </p:txBody>
+      </p:sp>
+      <p:sp>
+        <p:nvSpPr>
+          <p:cNvPr id="26" name="Benefit Title 2"/>
+          <p:cNvSpPr txBox="1"/>
+          <p:nvPr/>
+        </p:nvSpPr>
+        <p:spPr>
+          <a:xfrm>
+            <a:off x="7635240" y="1828800"/>
+            <a:ext cx="3474720" cy="411480"/>
+          </a:xfrm>
+          <a:prstGeom prst="rect">
+            <a:avLst/>
+          </a:prstGeom>
+          <a:noFill/>
+        </p:spPr>
+        <p:txBody>
+          <a:bodyPr wrap="square" lIns="0" tIns="0" rIns="0" bIns="0" anchor="t"/>
+          <a:lstStyle/>
+          <a:p>
+            <a:pPr algn="l"/>
+            <a:r>
+              <a:rPr lang="en-US" sz="1800" b="1">
+                <a:solidFill>
+                  <a:srgbClr val="0B1F3A"/>
+                </a:solidFill>
+                <a:latin typeface="Calibri"/>
+              </a:rPr>
+              <a:t>No new tools to learn</a:t>
+            </a:r>
+          </a:p>
+        </p:txBody>
+      </p:sp>
+      <p:sp>
+        <p:nvSpPr>
+          <p:cNvPr id="27" name="Benefit Desc 2"/>
+          <p:cNvSpPr txBox="1"/>
+          <p:nvPr/>
+        </p:nvSpPr>
+        <p:spPr>
+          <a:xfrm>
+            <a:off x="7635240" y="2286000"/>
+            <a:ext cx="3474720" cy="822960"/>
+          </a:xfrm>
+          <a:prstGeom prst="rect">
+            <a:avLst/>
+          </a:prstGeom>
+          <a:noFill/>
+        </p:spPr>
+        <p:txBody>
+          <a:bodyPr wrap="square" lIns="0" tIns="0" rIns="0" bIns="0" anchor="t"/>
+          <a:lstStyle/>
+          <a:p>
+            <a:pPr algn="l">
+              <a:lnSpc>
+                <a:spcPct val="115000"/>
+              </a:lnSpc>
+            </a:pPr>
+            <a:r>
+              <a:rPr lang="en-US" sz="1400" b="0">
+                <a:solidFill>
+                  <a:srgbClr val="5A6370"/>
+                </a:solidFill>
+                <a:latin typeface="Calibri"/>
+              </a:rPr>
+              <a:t>Plain English in — no SQL, no BI dashboards, no ticket queue.</a:t>
+            </a:r>
+          </a:p>
+        </p:txBody>
+      </p:sp>
+      <p:sp>
+        <p:nvSpPr>
+          <p:cNvPr id="28" name="Benefit Card 3"/>
+          <p:cNvSpPr/>
+          <p:nvPr/>
+        </p:nvSpPr>
+        <p:spPr>
+          <a:xfrm>
+            <a:off x="731520" y="3657600"/>
+            <a:ext cx="5212080" cy="1920240"/>
+          </a:xfrm>
+          <a:prstGeom prst="roundRect">
+            <a:avLst>
+              <a:gd name="adj" fmla="val 8000"/>
+            </a:avLst>
+          </a:prstGeom>
+          <a:solidFill>
+            <a:srgbClr val="F4F6F9"/>
+          </a:solidFill>
+          <a:ln>
+            <a:noFill/>
+          </a:ln>
+          <a:effectLst/>
+        </p:spPr>
+        <p:style>
+          <a:lnRef idx="1">
+            <a:schemeClr val="accent1"/>
+          </a:lnRef>
+          <a:fillRef idx="3">
+            <a:schemeClr val="accent1"/>
+          </a:fillRef>
+          <a:effectRef idx="2">
+            <a:schemeClr val="accent1"/>
+          </a:effectRef>
+          <a:fontRef idx="minor">
+            <a:schemeClr val="lt1"/>
+          </a:fontRef>
+        </p:style>
+        <p:txBody>
+          <a:bodyPr wrap="square" lIns="0" tIns="0" rIns="0" bIns="0" anchor="t"/>
+          <a:lstStyle/>
+          <a:p>
+            <a:pPr algn="l"/>
+          </a:p>
+        </p:txBody>
+      </p:sp>
+      <p:sp>
+        <p:nvSpPr>
+          <p:cNvPr id="29" name="Benefit Num 3"/>
+          <p:cNvSpPr/>
+          <p:nvPr/>
+        </p:nvSpPr>
+        <p:spPr>
+          <a:xfrm>
+            <a:off x="1097280" y="4069080"/>
+            <a:ext cx="731520" cy="731520"/>
+          </a:xfrm>
+          <a:prstGeom prst="ellipse">
+            <a:avLst/>
+          </a:prstGeom>
+          <a:solidFill>
+            <a:srgbClr val="0B1F3A"/>
+          </a:solidFill>
+          <a:ln>
+            <a:noFill/>
+          </a:ln>
+          <a:effectLst/>
+        </p:spPr>
+        <p:style>
+          <a:lnRef idx="1">
+            <a:schemeClr val="accent1"/>
+          </a:lnRef>
+          <a:fillRef idx="3">
+            <a:schemeClr val="accent1"/>
+          </a:fillRef>
+          <a:effectRef idx="2">
+            <a:schemeClr val="accent1"/>
+          </a:effectRef>
+          <a:fontRef idx="minor">
+            <a:schemeClr val="lt1"/>
+          </a:fontRef>
+        </p:style>
+        <p:txBody>
+          <a:bodyPr wrap="square" lIns="0" tIns="0" rIns="0" bIns="0" anchor="ctr"/>
+          <a:lstStyle/>
+          <a:p>
+            <a:pPr algn="ctr"/>
+            <a:r>
+              <a:rPr lang="en-US" sz="2400" b="1">
+                <a:solidFill>
+                  <a:srgbClr val="FFFFFF"/>
+                </a:solidFill>
+                <a:latin typeface="Calibri"/>
+              </a:rPr>
+              <a:t>3</a:t>
+            </a:r>
+          </a:p>
+        </p:txBody>
+      </p:sp>
+      <p:sp>
+        <p:nvSpPr>
+          <p:cNvPr id="30" name="Benefit Title 3"/>
+          <p:cNvSpPr txBox="1"/>
+          <p:nvPr/>
+        </p:nvSpPr>
+        <p:spPr>
+          <a:xfrm>
+            <a:off x="2103120" y="4069080"/>
+            <a:ext cx="3474720" cy="411480"/>
+          </a:xfrm>
+          <a:prstGeom prst="rect">
+            <a:avLst/>
+          </a:prstGeom>
+          <a:noFill/>
+        </p:spPr>
+        <p:txBody>
+          <a:bodyPr wrap="square" lIns="0" tIns="0" rIns="0" bIns="0" anchor="t"/>
+          <a:lstStyle/>
+          <a:p>
+            <a:pPr algn="l"/>
+            <a:r>
+              <a:rPr lang="en-US" sz="1800" b="1">
+                <a:solidFill>
+                  <a:srgbClr val="0B1F3A"/>
+                </a:solidFill>
+                <a:latin typeface="Calibri"/>
+              </a:rPr>
+              <a:t>Trustworthy by design</a:t>
+            </a:r>
+          </a:p>
+        </p:txBody>
+      </p:sp>
+      <p:sp>
+        <p:nvSpPr>
+          <p:cNvPr id="31" name="Benefit Desc 3"/>
+          <p:cNvSpPr txBox="1"/>
+          <p:nvPr/>
+        </p:nvSpPr>
+        <p:spPr>
+          <a:xfrm>
+            <a:off x="2103120" y="4526280"/>
+            <a:ext cx="3474720" cy="822960"/>
+          </a:xfrm>
+          <a:prstGeom prst="rect">
+            <a:avLst/>
+          </a:prstGeom>
+          <a:noFill/>
+        </p:spPr>
+        <p:txBody>
+          <a:bodyPr wrap="square" lIns="0" tIns="0" rIns="0" bIns="0" anchor="t"/>
+          <a:lstStyle/>
+          <a:p>
+            <a:pPr algn="l">
+              <a:lnSpc>
+                <a:spcPct val="115000"/>
+              </a:lnSpc>
+            </a:pPr>
+            <a:r>
+              <a:rPr lang="en-US" sz="1400" b="0">
+                <a:solidFill>
+                  <a:srgbClr val="5A6370"/>
+                </a:solidFill>
+                <a:latin typeface="Calibri"/>
+              </a:rPr>
+              <a:t>Every answer shows its SQL or source citation, so it can be verified.</a:t>
+            </a:r>
+          </a:p>
+        </p:txBody>
+      </p:sp>
+      <p:sp>
+        <p:nvSpPr>
+          <p:cNvPr id="32" name="Benefit Card 4"/>
+          <p:cNvSpPr/>
+          <p:nvPr/>
+        </p:nvSpPr>
+        <p:spPr>
+          <a:xfrm>
+            <a:off x="6263640" y="3657600"/>
+            <a:ext cx="5212080" cy="1920240"/>
+          </a:xfrm>
+          <a:prstGeom prst="roundRect">
+            <a:avLst>
+              <a:gd name="adj" fmla="val 8000"/>
+            </a:avLst>
+          </a:prstGeom>
+          <a:solidFill>
+            <a:srgbClr val="F4F6F9"/>
+          </a:solidFill>
+          <a:ln>
+            <a:noFill/>
+          </a:ln>
+          <a:effectLst/>
+        </p:spPr>
+        <p:style>
+          <a:lnRef idx="1">
+            <a:schemeClr val="accent1"/>
+          </a:lnRef>
+          <a:fillRef idx="3">
+            <a:schemeClr val="accent1"/>
+          </a:fillRef>
+          <a:effectRef idx="2">
+            <a:schemeClr val="accent1"/>
+          </a:effectRef>
+          <a:fontRef idx="minor">
+            <a:schemeClr val="lt1"/>
+          </a:fontRef>
+        </p:style>
+        <p:txBody>
+          <a:bodyPr wrap="square" lIns="0" tIns="0" rIns="0" bIns="0" anchor="t"/>
+          <a:lstStyle/>
+          <a:p>
+            <a:pPr algn="l"/>
+          </a:p>
+        </p:txBody>
+      </p:sp>
+      <p:sp>
+        <p:nvSpPr>
+          <p:cNvPr id="33" name="Benefit Num 4"/>
+          <p:cNvSpPr/>
+          <p:nvPr/>
+        </p:nvSpPr>
+        <p:spPr>
+          <a:xfrm>
+            <a:off x="6629400" y="4069080"/>
+            <a:ext cx="731520" cy="731520"/>
+          </a:xfrm>
+          <a:prstGeom prst="ellipse">
+            <a:avLst/>
+          </a:prstGeom>
+          <a:solidFill>
+            <a:srgbClr val="0B1F3A"/>
+          </a:solidFill>
+          <a:ln>
+            <a:noFill/>
+          </a:ln>
+          <a:effectLst/>
+        </p:spPr>
+        <p:style>
+          <a:lnRef idx="1">
+            <a:schemeClr val="accent1"/>
+          </a:lnRef>
+          <a:fillRef idx="3">
+            <a:schemeClr val="accent1"/>
+          </a:fillRef>
+          <a:effectRef idx="2">
+            <a:schemeClr val="accent1"/>
+          </a:effectRef>
+          <a:fontRef idx="minor">
+            <a:schemeClr val="lt1"/>
+          </a:fontRef>
+        </p:style>
+        <p:txBody>
+          <a:bodyPr wrap="square" lIns="0" tIns="0" rIns="0" bIns="0" anchor="ctr"/>
+          <a:lstStyle/>
+          <a:p>
+            <a:pPr algn="ctr"/>
+            <a:r>
+              <a:rPr lang="en-US" sz="2400" b="1">
+                <a:solidFill>
+                  <a:srgbClr val="FFFFFF"/>
+                </a:solidFill>
+                <a:latin typeface="Calibri"/>
+              </a:rPr>
+              <a:t>4</a:t>
+            </a:r>
+          </a:p>
+        </p:txBody>
+      </p:sp>
+      <p:sp>
+        <p:nvSpPr>
+          <p:cNvPr id="34" name="Benefit Title 4"/>
+          <p:cNvSpPr txBox="1"/>
+          <p:nvPr/>
+        </p:nvSpPr>
+        <p:spPr>
+          <a:xfrm>
+            <a:off x="7635240" y="4069080"/>
+            <a:ext cx="3474720" cy="411480"/>
+          </a:xfrm>
+          <a:prstGeom prst="rect">
+            <a:avLst/>
+          </a:prstGeom>
+          <a:noFill/>
+        </p:spPr>
+        <p:txBody>
+          <a:bodyPr wrap="square" lIns="0" tIns="0" rIns="0" bIns="0" anchor="t"/>
+          <a:lstStyle/>
+          <a:p>
+            <a:pPr algn="l"/>
+            <a:r>
+              <a:rPr lang="en-US" sz="1800" b="1">
+                <a:solidFill>
+                  <a:srgbClr val="0B1F3A"/>
+                </a:solidFill>
+                <a:latin typeface="Calibri"/>
+              </a:rPr>
+              <a:t>One integration, many channels</a:t>
+            </a:r>
+          </a:p>
+        </p:txBody>
+      </p:sp>
+      <p:sp>
+        <p:nvSpPr>
+          <p:cNvPr id="35" name="Benefit Desc 4"/>
+          <p:cNvSpPr txBox="1"/>
+          <p:nvPr/>
+        </p:nvSpPr>
+        <p:spPr>
+          <a:xfrm>
+            <a:off x="7635240" y="4526280"/>
+            <a:ext cx="3474720" cy="822960"/>
+          </a:xfrm>
+          <a:prstGeom prst="rect">
+            <a:avLst/>
+          </a:prstGeom>
+          <a:noFill/>
+        </p:spPr>
+        <p:txBody>
+          <a:bodyPr wrap="square" lIns="0" tIns="0" rIns="0" bIns="0" anchor="t"/>
+          <a:lstStyle/>
+          <a:p>
+            <a:pPr algn="l">
+              <a:lnSpc>
+                <a:spcPct val="115000"/>
+              </a:lnSpc>
+            </a:pPr>
+            <a:r>
+              <a:rPr lang="en-US" sz="1400" b="0">
+                <a:solidFill>
+                  <a:srgbClr val="5A6370"/>
+                </a:solidFill>
+                <a:latin typeface="Calibri"/>
+              </a:rPr>
+              <a:t>The same agent serves Streamlit today and any MCP client tomorrow.</a:t>
+            </a:r>
+          </a:p>
+        </p:txBody>
+      </p:sp>
+      <p:sp>
+        <p:nvSpPr>
+          <p:cNvPr id="9" name="TextBox 8"/>
+          <p:cNvSpPr txBox="1"/>
+          <p:nvPr/>
+        </p:nvSpPr>
+        <p:spPr>
+          <a:xfrm>
+            <a:off x="457200" y="6473952"/>
+            <a:ext cx="5486400" cy="320040"/>
+          </a:xfrm>
+          <a:prstGeom prst="rect">
+            <a:avLst/>
+          </a:prstGeom>
+          <a:noFill/>
+        </p:spPr>
+        <p:txBody>
+          <a:bodyPr wrap="square" anchor="t">
+            <a:spAutoFit/>
+          </a:bodyPr>
+          <a:lstStyle/>
+          <a:p>
+            <a:pPr algn="l">
+              <a:lnSpc>
+                <a:spcPct val="100000"/>
+              </a:lnSpc>
+            </a:pPr>
+            <a:r>
+              <a:rPr sz="900" b="0" i="1">
+                <a:solidFill>
+                  <a:srgbClr val="5A6370"/>
+                </a:solidFill>
+                <a:latin typeface="Calibri"/>
+              </a:rPr>
+              <a:t>Ansura  |  Capgemini × Snowflake Hackathon</a:t>
+            </a:r>
+          </a:p>
+        </p:txBody>
+      </p:sp>
+      <p:sp>
+        <p:nvSpPr>
+          <p:cNvPr id="10" name="TextBox 9"/>
+          <p:cNvSpPr txBox="1"/>
+          <p:nvPr/>
+        </p:nvSpPr>
+        <p:spPr>
+          <a:xfrm>
+            <a:off x="11247120" y="6473952"/>
+            <a:ext cx="731520" cy="320040"/>
+          </a:xfrm>
+          <a:prstGeom prst="rect">
+            <a:avLst/>
+          </a:prstGeom>
+          <a:noFill/>
+        </p:spPr>
+        <p:txBody>
+          <a:bodyPr wrap="square" anchor="t">
+            <a:spAutoFit/>
+          </a:bodyPr>
+          <a:lstStyle/>
+          <a:p>
+            <a:pPr algn="r">
+              <a:lnSpc>
+                <a:spcPct val="100000"/>
+              </a:lnSpc>
+            </a:pPr>
+            <a:r>
+              <a:rPr sz="900" b="0" i="0">
+                <a:solidFill>
+                  <a:srgbClr val="5A6370"/>
+                </a:solidFill>
+                <a:latin typeface="Calibri"/>
+              </a:rPr>
+              <a:t>12</a:t>
             </a:r>
           </a:p>
         </p:txBody>
@@ -5269,905 +6179,6 @@
 </p:sld>
 </file>
 
-<file path=ppt/slides/slide15.xml><?xml version="1.0" encoding="utf-8"?>
-<p:sld xmlns:a="http://schemas.openxmlformats.org/drawingml/2006/main" xmlns:p="http://schemas.openxmlformats.org/presentationml/2006/main" xmlns:r="http://schemas.openxmlformats.org/officeDocument/2006/relationships">
-  <p:cSld>
-    <p:spTree>
-      <p:nvGrpSpPr>
-        <p:cNvPr id="1" name=""/>
-        <p:cNvGrpSpPr/>
-        <p:nvPr/>
-      </p:nvGrpSpPr>
-      <p:grpSpPr/>
-      <p:sp>
-        <p:nvSpPr>
-          <p:cNvPr id="2" name="Rectangle 1"/>
-          <p:cNvSpPr/>
-          <p:nvPr/>
-        </p:nvSpPr>
-        <p:spPr>
-          <a:xfrm>
-            <a:off x="0" y="0"/>
-            <a:ext cx="12191695" cy="6858000"/>
-          </a:xfrm>
-          <a:prstGeom prst="rect">
-            <a:avLst/>
-          </a:prstGeom>
-          <a:solidFill>
-            <a:srgbClr val="FFFFFF"/>
-          </a:solidFill>
-          <a:ln>
-            <a:noFill/>
-          </a:ln>
-          <a:effectLst/>
-        </p:spPr>
-        <p:style>
-          <a:lnRef idx="1">
-            <a:schemeClr val="accent1"/>
-          </a:lnRef>
-          <a:fillRef idx="3">
-            <a:schemeClr val="accent1"/>
-          </a:fillRef>
-          <a:effectRef idx="2">
-            <a:schemeClr val="accent1"/>
-          </a:effectRef>
-          <a:fontRef idx="minor">
-            <a:schemeClr val="lt1"/>
-          </a:fontRef>
-        </p:style>
-        <p:txBody>
-          <a:bodyPr rtlCol="0" anchor="ctr"/>
-          <a:lstStyle/>
-          <a:p>
-            <a:pPr algn="ctr"/>
-          </a:p>
-        </p:txBody>
-      </p:sp>
-      <p:sp>
-        <p:nvSpPr>
-          <p:cNvPr id="3" name="Rectangle 2"/>
-          <p:cNvSpPr/>
-          <p:nvPr/>
-        </p:nvSpPr>
-        <p:spPr>
-          <a:xfrm>
-            <a:off x="0" y="0"/>
-            <a:ext cx="12191695" cy="1051560"/>
-          </a:xfrm>
-          <a:prstGeom prst="rect">
-            <a:avLst/>
-          </a:prstGeom>
-          <a:solidFill>
-            <a:srgbClr val="0B1F3A"/>
-          </a:solidFill>
-          <a:ln>
-            <a:noFill/>
-          </a:ln>
-          <a:effectLst/>
-        </p:spPr>
-        <p:style>
-          <a:lnRef idx="1">
-            <a:schemeClr val="accent1"/>
-          </a:lnRef>
-          <a:fillRef idx="3">
-            <a:schemeClr val="accent1"/>
-          </a:fillRef>
-          <a:effectRef idx="2">
-            <a:schemeClr val="accent1"/>
-          </a:effectRef>
-          <a:fontRef idx="minor">
-            <a:schemeClr val="lt1"/>
-          </a:fontRef>
-        </p:style>
-        <p:txBody>
-          <a:bodyPr rtlCol="0" anchor="ctr"/>
-          <a:lstStyle/>
-          <a:p>
-            <a:pPr algn="ctr"/>
-          </a:p>
-        </p:txBody>
-      </p:sp>
-      <p:sp>
-        <p:nvSpPr>
-          <p:cNvPr id="4" name="TextBox 3"/>
-          <p:cNvSpPr txBox="1"/>
-          <p:nvPr/>
-        </p:nvSpPr>
-        <p:spPr>
-          <a:xfrm>
-            <a:off x="548640" y="256032"/>
-            <a:ext cx="7315200" cy="548640"/>
-          </a:xfrm>
-          <a:prstGeom prst="rect">
-            <a:avLst/>
-          </a:prstGeom>
-          <a:noFill/>
-        </p:spPr>
-        <p:txBody>
-          <a:bodyPr wrap="square" anchor="t">
-            <a:spAutoFit/>
-          </a:bodyPr>
-          <a:lstStyle/>
-          <a:p>
-            <a:pPr algn="l">
-              <a:lnSpc>
-                <a:spcPct val="100000"/>
-              </a:lnSpc>
-            </a:pPr>
-            <a:r>
-              <a:rPr sz="3000" b="1" i="0">
-                <a:solidFill>
-                  <a:srgbClr val="FFFFFF"/>
-                </a:solidFill>
-                <a:latin typeface="Georgia"/>
-              </a:rPr>
-              <a:t>Benefits</a:t>
-            </a:r>
-          </a:p>
-        </p:txBody>
-      </p:sp>
-      <p:sp>
-        <p:nvSpPr>
-          <p:cNvPr id="20" name="Benefit Card 1"/>
-          <p:cNvSpPr/>
-          <p:nvPr/>
-        </p:nvSpPr>
-        <p:spPr>
-          <a:xfrm>
-            <a:off x="731520" y="1417320"/>
-            <a:ext cx="5212080" cy="1920240"/>
-          </a:xfrm>
-          <a:prstGeom prst="roundRect">
-            <a:avLst>
-              <a:gd name="adj" fmla="val 8000"/>
-            </a:avLst>
-          </a:prstGeom>
-          <a:solidFill>
-            <a:srgbClr val="F4F6F9"/>
-          </a:solidFill>
-          <a:ln>
-            <a:noFill/>
-          </a:ln>
-          <a:effectLst/>
-        </p:spPr>
-        <p:style>
-          <a:lnRef idx="1">
-            <a:schemeClr val="accent1"/>
-          </a:lnRef>
-          <a:fillRef idx="3">
-            <a:schemeClr val="accent1"/>
-          </a:fillRef>
-          <a:effectRef idx="2">
-            <a:schemeClr val="accent1"/>
-          </a:effectRef>
-          <a:fontRef idx="minor">
-            <a:schemeClr val="lt1"/>
-          </a:fontRef>
-        </p:style>
-        <p:txBody>
-          <a:bodyPr wrap="square" lIns="0" tIns="0" rIns="0" bIns="0" anchor="t"/>
-          <a:lstStyle/>
-          <a:p>
-            <a:pPr algn="l"/>
-          </a:p>
-        </p:txBody>
-      </p:sp>
-      <p:sp>
-        <p:nvSpPr>
-          <p:cNvPr id="21" name="Benefit Num 1"/>
-          <p:cNvSpPr/>
-          <p:nvPr/>
-        </p:nvSpPr>
-        <p:spPr>
-          <a:xfrm>
-            <a:off x="1097280" y="1828800"/>
-            <a:ext cx="731520" cy="731520"/>
-          </a:xfrm>
-          <a:prstGeom prst="ellipse">
-            <a:avLst/>
-          </a:prstGeom>
-          <a:solidFill>
-            <a:srgbClr val="0B1F3A"/>
-          </a:solidFill>
-          <a:ln>
-            <a:noFill/>
-          </a:ln>
-          <a:effectLst/>
-        </p:spPr>
-        <p:style>
-          <a:lnRef idx="1">
-            <a:schemeClr val="accent1"/>
-          </a:lnRef>
-          <a:fillRef idx="3">
-            <a:schemeClr val="accent1"/>
-          </a:fillRef>
-          <a:effectRef idx="2">
-            <a:schemeClr val="accent1"/>
-          </a:effectRef>
-          <a:fontRef idx="minor">
-            <a:schemeClr val="lt1"/>
-          </a:fontRef>
-        </p:style>
-        <p:txBody>
-          <a:bodyPr wrap="square" lIns="0" tIns="0" rIns="0" bIns="0" anchor="ctr"/>
-          <a:lstStyle/>
-          <a:p>
-            <a:pPr algn="ctr"/>
-            <a:r>
-              <a:rPr lang="en-US" sz="2400" b="1">
-                <a:solidFill>
-                  <a:srgbClr val="FFFFFF"/>
-                </a:solidFill>
-                <a:latin typeface="Calibri"/>
-              </a:rPr>
-              <a:t>1</a:t>
-            </a:r>
-          </a:p>
-        </p:txBody>
-      </p:sp>
-      <p:sp>
-        <p:nvSpPr>
-          <p:cNvPr id="22" name="Benefit Title 1"/>
-          <p:cNvSpPr txBox="1"/>
-          <p:nvPr/>
-        </p:nvSpPr>
-        <p:spPr>
-          <a:xfrm>
-            <a:off x="2103120" y="1828800"/>
-            <a:ext cx="3474720" cy="411480"/>
-          </a:xfrm>
-          <a:prstGeom prst="rect">
-            <a:avLst/>
-          </a:prstGeom>
-          <a:noFill/>
-        </p:spPr>
-        <p:txBody>
-          <a:bodyPr wrap="square" lIns="0" tIns="0" rIns="0" bIns="0" anchor="t"/>
-          <a:lstStyle/>
-          <a:p>
-            <a:pPr algn="l"/>
-            <a:r>
-              <a:rPr lang="en-US" sz="1800" b="1">
-                <a:solidFill>
-                  <a:srgbClr val="0B1F3A"/>
-                </a:solidFill>
-                <a:latin typeface="Calibri"/>
-              </a:rPr>
-              <a:t>Faster answers</a:t>
-            </a:r>
-          </a:p>
-        </p:txBody>
-      </p:sp>
-      <p:sp>
-        <p:nvSpPr>
-          <p:cNvPr id="23" name="Benefit Desc 1"/>
-          <p:cNvSpPr txBox="1"/>
-          <p:nvPr/>
-        </p:nvSpPr>
-        <p:spPr>
-          <a:xfrm>
-            <a:off x="2103120" y="2286000"/>
-            <a:ext cx="3474720" cy="822960"/>
-          </a:xfrm>
-          <a:prstGeom prst="rect">
-            <a:avLst/>
-          </a:prstGeom>
-          <a:noFill/>
-        </p:spPr>
-        <p:txBody>
-          <a:bodyPr wrap="square" lIns="0" tIns="0" rIns="0" bIns="0" anchor="t"/>
-          <a:lstStyle/>
-          <a:p>
-            <a:pPr algn="l">
-              <a:lnSpc>
-                <a:spcPct val="115000"/>
-              </a:lnSpc>
-            </a:pPr>
-            <a:r>
-              <a:rPr lang="en-US" sz="1400" b="0">
-                <a:solidFill>
-                  <a:srgbClr val="5A6370"/>
-                </a:solidFill>
-                <a:latin typeface="Calibri"/>
-              </a:rPr>
-              <a:t>Hours of waiting on a specialist collapse into a single conversation.</a:t>
-            </a:r>
-          </a:p>
-        </p:txBody>
-      </p:sp>
-      <p:sp>
-        <p:nvSpPr>
-          <p:cNvPr id="24" name="Benefit Card 2"/>
-          <p:cNvSpPr/>
-          <p:nvPr/>
-        </p:nvSpPr>
-        <p:spPr>
-          <a:xfrm>
-            <a:off x="6263640" y="1417320"/>
-            <a:ext cx="5212080" cy="1920240"/>
-          </a:xfrm>
-          <a:prstGeom prst="roundRect">
-            <a:avLst>
-              <a:gd name="adj" fmla="val 8000"/>
-            </a:avLst>
-          </a:prstGeom>
-          <a:solidFill>
-            <a:srgbClr val="F4F6F9"/>
-          </a:solidFill>
-          <a:ln>
-            <a:noFill/>
-          </a:ln>
-          <a:effectLst/>
-        </p:spPr>
-        <p:style>
-          <a:lnRef idx="1">
-            <a:schemeClr val="accent1"/>
-          </a:lnRef>
-          <a:fillRef idx="3">
-            <a:schemeClr val="accent1"/>
-          </a:fillRef>
-          <a:effectRef idx="2">
-            <a:schemeClr val="accent1"/>
-          </a:effectRef>
-          <a:fontRef idx="minor">
-            <a:schemeClr val="lt1"/>
-          </a:fontRef>
-        </p:style>
-        <p:txBody>
-          <a:bodyPr wrap="square" lIns="0" tIns="0" rIns="0" bIns="0" anchor="t"/>
-          <a:lstStyle/>
-          <a:p>
-            <a:pPr algn="l"/>
-          </a:p>
-        </p:txBody>
-      </p:sp>
-      <p:sp>
-        <p:nvSpPr>
-          <p:cNvPr id="25" name="Benefit Num 2"/>
-          <p:cNvSpPr/>
-          <p:nvPr/>
-        </p:nvSpPr>
-        <p:spPr>
-          <a:xfrm>
-            <a:off x="6629400" y="1828800"/>
-            <a:ext cx="731520" cy="731520"/>
-          </a:xfrm>
-          <a:prstGeom prst="ellipse">
-            <a:avLst/>
-          </a:prstGeom>
-          <a:solidFill>
-            <a:srgbClr val="0B1F3A"/>
-          </a:solidFill>
-          <a:ln>
-            <a:noFill/>
-          </a:ln>
-          <a:effectLst/>
-        </p:spPr>
-        <p:style>
-          <a:lnRef idx="1">
-            <a:schemeClr val="accent1"/>
-          </a:lnRef>
-          <a:fillRef idx="3">
-            <a:schemeClr val="accent1"/>
-          </a:fillRef>
-          <a:effectRef idx="2">
-            <a:schemeClr val="accent1"/>
-          </a:effectRef>
-          <a:fontRef idx="minor">
-            <a:schemeClr val="lt1"/>
-          </a:fontRef>
-        </p:style>
-        <p:txBody>
-          <a:bodyPr wrap="square" lIns="0" tIns="0" rIns="0" bIns="0" anchor="ctr"/>
-          <a:lstStyle/>
-          <a:p>
-            <a:pPr algn="ctr"/>
-            <a:r>
-              <a:rPr lang="en-US" sz="2400" b="1">
-                <a:solidFill>
-                  <a:srgbClr val="FFFFFF"/>
-                </a:solidFill>
-                <a:latin typeface="Calibri"/>
-              </a:rPr>
-              <a:t>2</a:t>
-            </a:r>
-          </a:p>
-        </p:txBody>
-      </p:sp>
-      <p:sp>
-        <p:nvSpPr>
-          <p:cNvPr id="26" name="Benefit Title 2"/>
-          <p:cNvSpPr txBox="1"/>
-          <p:nvPr/>
-        </p:nvSpPr>
-        <p:spPr>
-          <a:xfrm>
-            <a:off x="7635240" y="1828800"/>
-            <a:ext cx="3474720" cy="411480"/>
-          </a:xfrm>
-          <a:prstGeom prst="rect">
-            <a:avLst/>
-          </a:prstGeom>
-          <a:noFill/>
-        </p:spPr>
-        <p:txBody>
-          <a:bodyPr wrap="square" lIns="0" tIns="0" rIns="0" bIns="0" anchor="t"/>
-          <a:lstStyle/>
-          <a:p>
-            <a:pPr algn="l"/>
-            <a:r>
-              <a:rPr lang="en-US" sz="1800" b="1">
-                <a:solidFill>
-                  <a:srgbClr val="0B1F3A"/>
-                </a:solidFill>
-                <a:latin typeface="Calibri"/>
-              </a:rPr>
-              <a:t>No new tools to learn</a:t>
-            </a:r>
-          </a:p>
-        </p:txBody>
-      </p:sp>
-      <p:sp>
-        <p:nvSpPr>
-          <p:cNvPr id="27" name="Benefit Desc 2"/>
-          <p:cNvSpPr txBox="1"/>
-          <p:nvPr/>
-        </p:nvSpPr>
-        <p:spPr>
-          <a:xfrm>
-            <a:off x="7635240" y="2286000"/>
-            <a:ext cx="3474720" cy="822960"/>
-          </a:xfrm>
-          <a:prstGeom prst="rect">
-            <a:avLst/>
-          </a:prstGeom>
-          <a:noFill/>
-        </p:spPr>
-        <p:txBody>
-          <a:bodyPr wrap="square" lIns="0" tIns="0" rIns="0" bIns="0" anchor="t"/>
-          <a:lstStyle/>
-          <a:p>
-            <a:pPr algn="l">
-              <a:lnSpc>
-                <a:spcPct val="115000"/>
-              </a:lnSpc>
-            </a:pPr>
-            <a:r>
-              <a:rPr lang="en-US" sz="1400" b="0">
-                <a:solidFill>
-                  <a:srgbClr val="5A6370"/>
-                </a:solidFill>
-                <a:latin typeface="Calibri"/>
-              </a:rPr>
-              <a:t>Plain English in — no SQL, no BI dashboards, no ticket queue.</a:t>
-            </a:r>
-          </a:p>
-        </p:txBody>
-      </p:sp>
-      <p:sp>
-        <p:nvSpPr>
-          <p:cNvPr id="28" name="Benefit Card 3"/>
-          <p:cNvSpPr/>
-          <p:nvPr/>
-        </p:nvSpPr>
-        <p:spPr>
-          <a:xfrm>
-            <a:off x="731520" y="3657600"/>
-            <a:ext cx="5212080" cy="1920240"/>
-          </a:xfrm>
-          <a:prstGeom prst="roundRect">
-            <a:avLst>
-              <a:gd name="adj" fmla="val 8000"/>
-            </a:avLst>
-          </a:prstGeom>
-          <a:solidFill>
-            <a:srgbClr val="F4F6F9"/>
-          </a:solidFill>
-          <a:ln>
-            <a:noFill/>
-          </a:ln>
-          <a:effectLst/>
-        </p:spPr>
-        <p:style>
-          <a:lnRef idx="1">
-            <a:schemeClr val="accent1"/>
-          </a:lnRef>
-          <a:fillRef idx="3">
-            <a:schemeClr val="accent1"/>
-          </a:fillRef>
-          <a:effectRef idx="2">
-            <a:schemeClr val="accent1"/>
-          </a:effectRef>
-          <a:fontRef idx="minor">
-            <a:schemeClr val="lt1"/>
-          </a:fontRef>
-        </p:style>
-        <p:txBody>
-          <a:bodyPr wrap="square" lIns="0" tIns="0" rIns="0" bIns="0" anchor="t"/>
-          <a:lstStyle/>
-          <a:p>
-            <a:pPr algn="l"/>
-          </a:p>
-        </p:txBody>
-      </p:sp>
-      <p:sp>
-        <p:nvSpPr>
-          <p:cNvPr id="29" name="Benefit Num 3"/>
-          <p:cNvSpPr/>
-          <p:nvPr/>
-        </p:nvSpPr>
-        <p:spPr>
-          <a:xfrm>
-            <a:off x="1097280" y="4069080"/>
-            <a:ext cx="731520" cy="731520"/>
-          </a:xfrm>
-          <a:prstGeom prst="ellipse">
-            <a:avLst/>
-          </a:prstGeom>
-          <a:solidFill>
-            <a:srgbClr val="0B1F3A"/>
-          </a:solidFill>
-          <a:ln>
-            <a:noFill/>
-          </a:ln>
-          <a:effectLst/>
-        </p:spPr>
-        <p:style>
-          <a:lnRef idx="1">
-            <a:schemeClr val="accent1"/>
-          </a:lnRef>
-          <a:fillRef idx="3">
-            <a:schemeClr val="accent1"/>
-          </a:fillRef>
-          <a:effectRef idx="2">
-            <a:schemeClr val="accent1"/>
-          </a:effectRef>
-          <a:fontRef idx="minor">
-            <a:schemeClr val="lt1"/>
-          </a:fontRef>
-        </p:style>
-        <p:txBody>
-          <a:bodyPr wrap="square" lIns="0" tIns="0" rIns="0" bIns="0" anchor="ctr"/>
-          <a:lstStyle/>
-          <a:p>
-            <a:pPr algn="ctr"/>
-            <a:r>
-              <a:rPr lang="en-US" sz="2400" b="1">
-                <a:solidFill>
-                  <a:srgbClr val="FFFFFF"/>
-                </a:solidFill>
-                <a:latin typeface="Calibri"/>
-              </a:rPr>
-              <a:t>3</a:t>
-            </a:r>
-          </a:p>
-        </p:txBody>
-      </p:sp>
-      <p:sp>
-        <p:nvSpPr>
-          <p:cNvPr id="30" name="Benefit Title 3"/>
-          <p:cNvSpPr txBox="1"/>
-          <p:nvPr/>
-        </p:nvSpPr>
-        <p:spPr>
-          <a:xfrm>
-            <a:off x="2103120" y="4069080"/>
-            <a:ext cx="3474720" cy="411480"/>
-          </a:xfrm>
-          <a:prstGeom prst="rect">
-            <a:avLst/>
-          </a:prstGeom>
-          <a:noFill/>
-        </p:spPr>
-        <p:txBody>
-          <a:bodyPr wrap="square" lIns="0" tIns="0" rIns="0" bIns="0" anchor="t"/>
-          <a:lstStyle/>
-          <a:p>
-            <a:pPr algn="l"/>
-            <a:r>
-              <a:rPr lang="en-US" sz="1800" b="1">
-                <a:solidFill>
-                  <a:srgbClr val="0B1F3A"/>
-                </a:solidFill>
-                <a:latin typeface="Calibri"/>
-              </a:rPr>
-              <a:t>Trustworthy by design</a:t>
-            </a:r>
-          </a:p>
-        </p:txBody>
-      </p:sp>
-      <p:sp>
-        <p:nvSpPr>
-          <p:cNvPr id="31" name="Benefit Desc 3"/>
-          <p:cNvSpPr txBox="1"/>
-          <p:nvPr/>
-        </p:nvSpPr>
-        <p:spPr>
-          <a:xfrm>
-            <a:off x="2103120" y="4526280"/>
-            <a:ext cx="3474720" cy="822960"/>
-          </a:xfrm>
-          <a:prstGeom prst="rect">
-            <a:avLst/>
-          </a:prstGeom>
-          <a:noFill/>
-        </p:spPr>
-        <p:txBody>
-          <a:bodyPr wrap="square" lIns="0" tIns="0" rIns="0" bIns="0" anchor="t"/>
-          <a:lstStyle/>
-          <a:p>
-            <a:pPr algn="l">
-              <a:lnSpc>
-                <a:spcPct val="115000"/>
-              </a:lnSpc>
-            </a:pPr>
-            <a:r>
-              <a:rPr lang="en-US" sz="1400" b="0">
-                <a:solidFill>
-                  <a:srgbClr val="5A6370"/>
-                </a:solidFill>
-                <a:latin typeface="Calibri"/>
-              </a:rPr>
-              <a:t>Every answer shows its SQL or source citation, so it can be verified.</a:t>
-            </a:r>
-          </a:p>
-        </p:txBody>
-      </p:sp>
-      <p:sp>
-        <p:nvSpPr>
-          <p:cNvPr id="32" name="Benefit Card 4"/>
-          <p:cNvSpPr/>
-          <p:nvPr/>
-        </p:nvSpPr>
-        <p:spPr>
-          <a:xfrm>
-            <a:off x="6263640" y="3657600"/>
-            <a:ext cx="5212080" cy="1920240"/>
-          </a:xfrm>
-          <a:prstGeom prst="roundRect">
-            <a:avLst>
-              <a:gd name="adj" fmla="val 8000"/>
-            </a:avLst>
-          </a:prstGeom>
-          <a:solidFill>
-            <a:srgbClr val="F4F6F9"/>
-          </a:solidFill>
-          <a:ln>
-            <a:noFill/>
-          </a:ln>
-          <a:effectLst/>
-        </p:spPr>
-        <p:style>
-          <a:lnRef idx="1">
-            <a:schemeClr val="accent1"/>
-          </a:lnRef>
-          <a:fillRef idx="3">
-            <a:schemeClr val="accent1"/>
-          </a:fillRef>
-          <a:effectRef idx="2">
-            <a:schemeClr val="accent1"/>
-          </a:effectRef>
-          <a:fontRef idx="minor">
-            <a:schemeClr val="lt1"/>
-          </a:fontRef>
-        </p:style>
-        <p:txBody>
-          <a:bodyPr wrap="square" lIns="0" tIns="0" rIns="0" bIns="0" anchor="t"/>
-          <a:lstStyle/>
-          <a:p>
-            <a:pPr algn="l"/>
-          </a:p>
-        </p:txBody>
-      </p:sp>
-      <p:sp>
-        <p:nvSpPr>
-          <p:cNvPr id="33" name="Benefit Num 4"/>
-          <p:cNvSpPr/>
-          <p:nvPr/>
-        </p:nvSpPr>
-        <p:spPr>
-          <a:xfrm>
-            <a:off x="6629400" y="4069080"/>
-            <a:ext cx="731520" cy="731520"/>
-          </a:xfrm>
-          <a:prstGeom prst="ellipse">
-            <a:avLst/>
-          </a:prstGeom>
-          <a:solidFill>
-            <a:srgbClr val="0B1F3A"/>
-          </a:solidFill>
-          <a:ln>
-            <a:noFill/>
-          </a:ln>
-          <a:effectLst/>
-        </p:spPr>
-        <p:style>
-          <a:lnRef idx="1">
-            <a:schemeClr val="accent1"/>
-          </a:lnRef>
-          <a:fillRef idx="3">
-            <a:schemeClr val="accent1"/>
-          </a:fillRef>
-          <a:effectRef idx="2">
-            <a:schemeClr val="accent1"/>
-          </a:effectRef>
-          <a:fontRef idx="minor">
-            <a:schemeClr val="lt1"/>
-          </a:fontRef>
-        </p:style>
-        <p:txBody>
-          <a:bodyPr wrap="square" lIns="0" tIns="0" rIns="0" bIns="0" anchor="ctr"/>
-          <a:lstStyle/>
-          <a:p>
-            <a:pPr algn="ctr"/>
-            <a:r>
-              <a:rPr lang="en-US" sz="2400" b="1">
-                <a:solidFill>
-                  <a:srgbClr val="FFFFFF"/>
-                </a:solidFill>
-                <a:latin typeface="Calibri"/>
-              </a:rPr>
-              <a:t>4</a:t>
-            </a:r>
-          </a:p>
-        </p:txBody>
-      </p:sp>
-      <p:sp>
-        <p:nvSpPr>
-          <p:cNvPr id="34" name="Benefit Title 4"/>
-          <p:cNvSpPr txBox="1"/>
-          <p:nvPr/>
-        </p:nvSpPr>
-        <p:spPr>
-          <a:xfrm>
-            <a:off x="7635240" y="4069080"/>
-            <a:ext cx="3474720" cy="411480"/>
-          </a:xfrm>
-          <a:prstGeom prst="rect">
-            <a:avLst/>
-          </a:prstGeom>
-          <a:noFill/>
-        </p:spPr>
-        <p:txBody>
-          <a:bodyPr wrap="square" lIns="0" tIns="0" rIns="0" bIns="0" anchor="t"/>
-          <a:lstStyle/>
-          <a:p>
-            <a:pPr algn="l"/>
-            <a:r>
-              <a:rPr lang="en-US" sz="1800" b="1">
-                <a:solidFill>
-                  <a:srgbClr val="0B1F3A"/>
-                </a:solidFill>
-                <a:latin typeface="Calibri"/>
-              </a:rPr>
-              <a:t>One integration, many channels</a:t>
-            </a:r>
-          </a:p>
-        </p:txBody>
-      </p:sp>
-      <p:sp>
-        <p:nvSpPr>
-          <p:cNvPr id="35" name="Benefit Desc 4"/>
-          <p:cNvSpPr txBox="1"/>
-          <p:nvPr/>
-        </p:nvSpPr>
-        <p:spPr>
-          <a:xfrm>
-            <a:off x="7635240" y="4526280"/>
-            <a:ext cx="3474720" cy="822960"/>
-          </a:xfrm>
-          <a:prstGeom prst="rect">
-            <a:avLst/>
-          </a:prstGeom>
-          <a:noFill/>
-        </p:spPr>
-        <p:txBody>
-          <a:bodyPr wrap="square" lIns="0" tIns="0" rIns="0" bIns="0" anchor="t"/>
-          <a:lstStyle/>
-          <a:p>
-            <a:pPr algn="l">
-              <a:lnSpc>
-                <a:spcPct val="115000"/>
-              </a:lnSpc>
-            </a:pPr>
-            <a:r>
-              <a:rPr lang="en-US" sz="1400" b="0">
-                <a:solidFill>
-                  <a:srgbClr val="5A6370"/>
-                </a:solidFill>
-                <a:latin typeface="Calibri"/>
-              </a:rPr>
-              <a:t>The same agent serves Streamlit today and any MCP client tomorrow.</a:t>
-            </a:r>
-          </a:p>
-        </p:txBody>
-      </p:sp>
-      <p:sp>
-        <p:nvSpPr>
-          <p:cNvPr id="9" name="TextBox 8"/>
-          <p:cNvSpPr txBox="1"/>
-          <p:nvPr/>
-        </p:nvSpPr>
-        <p:spPr>
-          <a:xfrm>
-            <a:off x="457200" y="6473952"/>
-            <a:ext cx="5486400" cy="320040"/>
-          </a:xfrm>
-          <a:prstGeom prst="rect">
-            <a:avLst/>
-          </a:prstGeom>
-          <a:noFill/>
-        </p:spPr>
-        <p:txBody>
-          <a:bodyPr wrap="square" anchor="t">
-            <a:spAutoFit/>
-          </a:bodyPr>
-          <a:lstStyle/>
-          <a:p>
-            <a:pPr algn="l">
-              <a:lnSpc>
-                <a:spcPct val="100000"/>
-              </a:lnSpc>
-            </a:pPr>
-            <a:r>
-              <a:rPr sz="900" b="0" i="1">
-                <a:solidFill>
-                  <a:srgbClr val="5A6370"/>
-                </a:solidFill>
-                <a:latin typeface="Calibri"/>
-              </a:rPr>
-              <a:t>Unified Enterprise AI Agents Platform  |  Capgemini × Snowflake Hackathon</a:t>
-            </a:r>
-          </a:p>
-        </p:txBody>
-      </p:sp>
-      <p:sp>
-        <p:nvSpPr>
-          <p:cNvPr id="10" name="TextBox 9"/>
-          <p:cNvSpPr txBox="1"/>
-          <p:nvPr/>
-        </p:nvSpPr>
-        <p:spPr>
-          <a:xfrm>
-            <a:off x="11247120" y="6473952"/>
-            <a:ext cx="731520" cy="320040"/>
-          </a:xfrm>
-          <a:prstGeom prst="rect">
-            <a:avLst/>
-          </a:prstGeom>
-          <a:noFill/>
-        </p:spPr>
-        <p:txBody>
-          <a:bodyPr wrap="square" anchor="t">
-            <a:spAutoFit/>
-          </a:bodyPr>
-          <a:lstStyle/>
-          <a:p>
-            <a:pPr algn="r">
-              <a:lnSpc>
-                <a:spcPct val="100000"/>
-              </a:lnSpc>
-            </a:pPr>
-            <a:r>
-              <a:rPr sz="900" b="0" i="0">
-                <a:solidFill>
-                  <a:srgbClr val="5A6370"/>
-                </a:solidFill>
-                <a:latin typeface="Calibri"/>
-              </a:rPr>
-              <a:t>12</a:t>
-            </a:r>
-          </a:p>
-        </p:txBody>
-      </p:sp>
-    </p:spTree>
-  </p:cSld>
-  <p:clrMapOvr>
-    <a:masterClrMapping/>
-  </p:clrMapOvr>
-</p:sld>
-</file>
-
 <file path=ppt/slides/slide2.xml><?xml version="1.0" encoding="utf-8"?>
 <p:sld xmlns:a="http://schemas.openxmlformats.org/drawingml/2006/main" xmlns:p="http://schemas.openxmlformats.org/presentationml/2006/main" xmlns:r="http://schemas.openxmlformats.org/officeDocument/2006/relationships">
   <p:cSld>
@@ -6474,7 +6485,7 @@
                 </a:solidFill>
                 <a:latin typeface="Calibri"/>
               </a:rPr>
-              <a:t>Unified Enterprise AI Agents Platform  |  Capgemini × Snowflake Hackathon</a:t>
+              <a:t>Ansura  |  Capgemini × Snowflake Hackathon</a:t>
             </a:r>
           </a:p>
         </p:txBody>
@@ -7532,7 +7543,7 @@
                 </a:solidFill>
                 <a:latin typeface="Calibri"/>
               </a:rPr>
-              <a:t>Unified Enterprise AI Agents Platform  |  Capgemini × Snowflake Hackathon</a:t>
+              <a:t>Ansura  |  Capgemini × Snowflake Hackathon</a:t>
             </a:r>
           </a:p>
         </p:txBody>
@@ -8309,7 +8320,7 @@
                 </a:solidFill>
                 <a:latin typeface="Calibri"/>
               </a:rPr>
-              <a:t>Unified Enterprise AI Agents Platform  |  Capgemini × Snowflake Hackathon</a:t>
+              <a:t>Ansura  |  Capgemini × Snowflake Hackathon</a:t>
             </a:r>
           </a:p>
         </p:txBody>
@@ -9722,7 +9733,7 @@
                 </a:solidFill>
                 <a:latin typeface="Calibri"/>
               </a:rPr>
-              <a:t>Unified Enterprise AI Agents Platform  |  Capgemini × Snowflake Hackathon</a:t>
+              <a:t>Ansura  |  Capgemini × Snowflake Hackathon</a:t>
             </a:r>
           </a:p>
         </p:txBody>
@@ -10333,7 +10344,7 @@
                 </a:solidFill>
                 <a:latin typeface="Calibri"/>
               </a:rPr>
-              <a:t>Unified Enterprise AI Agents Platform  |  Capgemini × Snowflake Hackathon</a:t>
+              <a:t>Ansura  |  Capgemini × Snowflake Hackathon</a:t>
             </a:r>
           </a:p>
         </p:txBody>
@@ -10944,7 +10955,7 @@
                 </a:solidFill>
                 <a:latin typeface="Calibri"/>
               </a:rPr>
-              <a:t>Unified Enterprise AI Agents Platform  |  Capgemini × Snowflake Hackathon</a:t>
+              <a:t>Ansura  |  Capgemini × Snowflake Hackathon</a:t>
             </a:r>
           </a:p>
         </p:txBody>
@@ -11555,7 +11566,7 @@
                 </a:solidFill>
                 <a:latin typeface="Calibri"/>
               </a:rPr>
-              <a:t>Unified Enterprise AI Agents Platform  |  Capgemini × Snowflake Hackathon</a:t>
+              <a:t>Ansura  |  Capgemini × Snowflake Hackathon</a:t>
             </a:r>
           </a:p>
         </p:txBody>
@@ -11802,7 +11813,7 @@
                 </a:solidFill>
                 <a:latin typeface="Calibri"/>
               </a:rPr>
-              <a:t>Unified Enterprise AI Agents Platform  |  Capgemini × Snowflake Hackathon</a:t>
+              <a:t>Ansura  |  Capgemini × Snowflake Hackathon</a:t>
             </a:r>
           </a:p>
         </p:txBody>

</xml_diff>

<commit_message>
Embed the Ansura avatar logo into pptx and PDF
Earlier rebrand only swapped the text ("Unified Enterprise AI Agents
Platform" -> "Ansura"); the actual logo artwork was never inserted
into these files. Adds it now:
- pptx title slide: centered avatar above the "Ansura" heading.
- PDF page 1: small avatar badge in the top-right corner.

Co-Authored-By: Claude Sonnet 5 <noreply@anthropic.com>
</commit_message>
<xml_diff>
--- a/docs/Unified_Enterprise_AI_Agents_Platform.pptx
+++ b/docs/Unified_Enterprise_AI_Agents_Platform.pptx
@@ -3498,6 +3498,30 @@
           </a:p>
         </p:txBody>
       </p:sp>
+      <p:pic>
+        <p:nvPicPr>
+          <p:cNvPr id="11" name="Picture 10" descr="ansura_avatar.png"/>
+          <p:cNvPicPr>
+            <a:picLocks noChangeAspect="1"/>
+          </p:cNvPicPr>
+          <p:nvPr/>
+        </p:nvPicPr>
+        <p:blipFill>
+          <a:blip r:embed="rId3"/>
+          <a:stretch>
+            <a:fillRect/>
+          </a:stretch>
+        </p:blipFill>
+        <p:spPr>
+          <a:xfrm>
+            <a:off x="5645847" y="1120000"/>
+            <a:ext cx="900000" cy="900000"/>
+          </a:xfrm>
+          <a:prstGeom prst="rect">
+            <a:avLst/>
+          </a:prstGeom>
+        </p:spPr>
+      </p:pic>
     </p:spTree>
   </p:cSld>
   <p:clrMapOvr>

</xml_diff>